<commit_message>
Upload slides for 11/07
</commit_message>
<xml_diff>
--- a/TEACHING/files/2019/1107/1107_dongqi.pptx
+++ b/TEACHING/files/2019/1107/1107_dongqi.pptx
@@ -235,7 +235,7 @@
           <a:p>
             <a:fld id="{349EA5D1-EA62-498B-8748-E87F906BFE97}" type="datetimeFigureOut">
               <a:rPr lang="en-US" smtClean="0"/>
-              <a:t>11/6/2019</a:t>
+              <a:t>11/7/2019</a:t>
             </a:fld>
             <a:endParaRPr lang="en-US"/>
           </a:p>
@@ -548,7 +548,7 @@
           <a:p>
             <a:r>
               <a:rPr lang="en-US" dirty="0"/>
-              <a:t>If d’ and d’’ has the considerable probability to generate y, then y is able to be released</a:t>
+              <a:t>We use the synthetic data y to represent d</a:t>
             </a:r>
           </a:p>
         </p:txBody>
@@ -570,7 +570,7 @@
           <a:p>
             <a:fld id="{EAE826E6-07E3-4CA6-BA08-B9A6E0BDBC70}" type="slidenum">
               <a:rPr lang="en-US" smtClean="0"/>
-              <a:t>5</a:t>
+              <a:t>4</a:t>
             </a:fld>
             <a:endParaRPr lang="en-US"/>
           </a:p>
@@ -579,7 +579,7 @@
     </p:spTree>
     <p:extLst>
       <p:ext uri="{BB962C8B-B14F-4D97-AF65-F5344CB8AC3E}">
-        <p14:creationId xmlns:p14="http://schemas.microsoft.com/office/powerpoint/2010/main" val="4112837543"/>
+        <p14:creationId xmlns:p14="http://schemas.microsoft.com/office/powerpoint/2010/main" val="1625917721"/>
       </p:ext>
     </p:extLst>
   </p:cSld>
@@ -590,6 +590,90 @@
 </file>
 
 <file path=ppt/notesSlides/notesSlide10.xml><?xml version="1.0" encoding="utf-8"?>
+<p:notes xmlns:a="http://schemas.openxmlformats.org/drawingml/2006/main" xmlns:r="http://schemas.openxmlformats.org/officeDocument/2006/relationships" xmlns:p="http://schemas.openxmlformats.org/presentationml/2006/main">
+  <p:cSld>
+    <p:spTree>
+      <p:nvGrpSpPr>
+        <p:cNvPr id="1" name=""/>
+        <p:cNvGrpSpPr/>
+        <p:nvPr/>
+      </p:nvGrpSpPr>
+      <p:grpSpPr>
+        <a:xfrm>
+          <a:off x="0" y="0"/>
+          <a:ext cx="0" cy="0"/>
+          <a:chOff x="0" y="0"/>
+          <a:chExt cx="0" cy="0"/>
+        </a:xfrm>
+      </p:grpSpPr>
+      <p:sp>
+        <p:nvSpPr>
+          <p:cNvPr id="2" name="Slide Image Placeholder 1"/>
+          <p:cNvSpPr>
+            <a:spLocks noGrp="1" noRot="1" noChangeAspect="1"/>
+          </p:cNvSpPr>
+          <p:nvPr>
+            <p:ph type="sldImg"/>
+          </p:nvPr>
+        </p:nvSpPr>
+        <p:spPr/>
+      </p:sp>
+      <p:sp>
+        <p:nvSpPr>
+          <p:cNvPr id="3" name="Notes Placeholder 2"/>
+          <p:cNvSpPr>
+            <a:spLocks noGrp="1"/>
+          </p:cNvSpPr>
+          <p:nvPr>
+            <p:ph type="body" idx="1"/>
+          </p:nvPr>
+        </p:nvSpPr>
+        <p:spPr/>
+        <p:txBody>
+          <a:bodyPr/>
+          <a:lstStyle/>
+          <a:p>
+            <a:endParaRPr lang="en-US" dirty="0"/>
+          </a:p>
+        </p:txBody>
+      </p:sp>
+      <p:sp>
+        <p:nvSpPr>
+          <p:cNvPr id="4" name="Slide Number Placeholder 3"/>
+          <p:cNvSpPr>
+            <a:spLocks noGrp="1"/>
+          </p:cNvSpPr>
+          <p:nvPr>
+            <p:ph type="sldNum" sz="quarter" idx="5"/>
+          </p:nvPr>
+        </p:nvSpPr>
+        <p:spPr/>
+        <p:txBody>
+          <a:bodyPr/>
+          <a:lstStyle/>
+          <a:p>
+            <a:fld id="{EAE826E6-07E3-4CA6-BA08-B9A6E0BDBC70}" type="slidenum">
+              <a:rPr lang="en-US" smtClean="0"/>
+              <a:t>13</a:t>
+            </a:fld>
+            <a:endParaRPr lang="en-US"/>
+          </a:p>
+        </p:txBody>
+      </p:sp>
+    </p:spTree>
+    <p:extLst>
+      <p:ext uri="{BB962C8B-B14F-4D97-AF65-F5344CB8AC3E}">
+        <p14:creationId xmlns:p14="http://schemas.microsoft.com/office/powerpoint/2010/main" val="3489210885"/>
+      </p:ext>
+    </p:extLst>
+  </p:cSld>
+  <p:clrMapOvr>
+    <a:masterClrMapping/>
+  </p:clrMapOvr>
+</p:notes>
+</file>
+
+<file path=ppt/notesSlides/notesSlide11.xml><?xml version="1.0" encoding="utf-8"?>
 <p:notes xmlns:a="http://schemas.openxmlformats.org/drawingml/2006/main" xmlns:r="http://schemas.openxmlformats.org/officeDocument/2006/relationships" xmlns:p="http://schemas.openxmlformats.org/presentationml/2006/main">
   <p:cSld>
     <p:spTree>
@@ -673,7 +757,7 @@
 </p:notes>
 </file>
 
-<file path=ppt/notesSlides/notesSlide11.xml><?xml version="1.0" encoding="utf-8"?>
+<file path=ppt/notesSlides/notesSlide12.xml><?xml version="1.0" encoding="utf-8"?>
 <p:notes xmlns:a="http://schemas.openxmlformats.org/drawingml/2006/main" xmlns:r="http://schemas.openxmlformats.org/officeDocument/2006/relationships" xmlns:p="http://schemas.openxmlformats.org/presentationml/2006/main">
   <p:cSld>
     <p:spTree>
@@ -757,7 +841,7 @@
 </p:notes>
 </file>
 
-<file path=ppt/notesSlides/notesSlide12.xml><?xml version="1.0" encoding="utf-8"?>
+<file path=ppt/notesSlides/notesSlide13.xml><?xml version="1.0" encoding="utf-8"?>
 <p:notes xmlns:a="http://schemas.openxmlformats.org/drawingml/2006/main" xmlns:r="http://schemas.openxmlformats.org/officeDocument/2006/relationships" xmlns:p="http://schemas.openxmlformats.org/presentationml/2006/main">
   <p:cSld>
     <p:spTree>
@@ -852,7 +936,7 @@
 </p:notes>
 </file>
 
-<file path=ppt/notesSlides/notesSlide13.xml><?xml version="1.0" encoding="utf-8"?>
+<file path=ppt/notesSlides/notesSlide14.xml><?xml version="1.0" encoding="utf-8"?>
 <p:notes xmlns:a="http://schemas.openxmlformats.org/drawingml/2006/main" xmlns:r="http://schemas.openxmlformats.org/officeDocument/2006/relationships" xmlns:p="http://schemas.openxmlformats.org/presentationml/2006/main">
   <p:cSld>
     <p:spTree>
@@ -936,7 +1020,7 @@
 </p:notes>
 </file>
 
-<file path=ppt/notesSlides/notesSlide14.xml><?xml version="1.0" encoding="utf-8"?>
+<file path=ppt/notesSlides/notesSlide15.xml><?xml version="1.0" encoding="utf-8"?>
 <p:notes xmlns:a="http://schemas.openxmlformats.org/drawingml/2006/main" xmlns:r="http://schemas.openxmlformats.org/officeDocument/2006/relationships" xmlns:p="http://schemas.openxmlformats.org/presentationml/2006/main">
   <p:cSld>
     <p:spTree>
@@ -980,6 +1064,35 @@
           <a:bodyPr/>
           <a:lstStyle/>
           <a:p>
+            <a:pPr marL="0" marR="0" lvl="0" indent="0" algn="l" defTabSz="914400" rtl="0" eaLnBrk="1" fontAlgn="auto" latinLnBrk="0" hangingPunct="1">
+              <a:lnSpc>
+                <a:spcPct val="100000"/>
+              </a:lnSpc>
+              <a:spcBef>
+                <a:spcPts val="0"/>
+              </a:spcBef>
+              <a:spcAft>
+                <a:spcPts val="0"/>
+              </a:spcAft>
+              <a:buClrTx/>
+              <a:buSzTx/>
+              <a:buFontTx/>
+              <a:buNone/>
+              <a:tabLst/>
+              <a:defRPr/>
+            </a:pPr>
+            <a:r>
+              <a:rPr lang="en-US" dirty="0">
+                <a:solidFill>
+                  <a:srgbClr val="13294B"/>
+                </a:solidFill>
+                <a:latin typeface="Calibri" charset="0"/>
+                <a:cs typeface="Calibri" charset="0"/>
+              </a:rPr>
+              <a:t>Machine learning task measures how good when the synthetic data serves different machine learning tasks</a:t>
+            </a:r>
+          </a:p>
+          <a:p>
             <a:endParaRPr lang="en-US" dirty="0"/>
           </a:p>
         </p:txBody>
@@ -1020,7 +1133,7 @@
 </p:notes>
 </file>
 
-<file path=ppt/notesSlides/notesSlide15.xml><?xml version="1.0" encoding="utf-8"?>
+<file path=ppt/notesSlides/notesSlide16.xml><?xml version="1.0" encoding="utf-8"?>
 <p:notes xmlns:a="http://schemas.openxmlformats.org/drawingml/2006/main" xmlns:r="http://schemas.openxmlformats.org/officeDocument/2006/relationships" xmlns:p="http://schemas.openxmlformats.org/presentationml/2006/main">
   <p:cSld>
     <p:spTree>
@@ -1104,7 +1217,7 @@
 </p:notes>
 </file>
 
-<file path=ppt/notesSlides/notesSlide16.xml><?xml version="1.0" encoding="utf-8"?>
+<file path=ppt/notesSlides/notesSlide17.xml><?xml version="1.0" encoding="utf-8"?>
 <p:notes xmlns:a="http://schemas.openxmlformats.org/drawingml/2006/main" xmlns:r="http://schemas.openxmlformats.org/officeDocument/2006/relationships" xmlns:p="http://schemas.openxmlformats.org/presentationml/2006/main">
   <p:cSld>
     <p:spTree>
@@ -1188,7 +1301,7 @@
 </p:notes>
 </file>
 
-<file path=ppt/notesSlides/notesSlide17.xml><?xml version="1.0" encoding="utf-8"?>
+<file path=ppt/notesSlides/notesSlide18.xml><?xml version="1.0" encoding="utf-8"?>
 <p:notes xmlns:a="http://schemas.openxmlformats.org/drawingml/2006/main" xmlns:r="http://schemas.openxmlformats.org/officeDocument/2006/relationships" xmlns:p="http://schemas.openxmlformats.org/presentationml/2006/main">
   <p:cSld>
     <p:spTree>
@@ -1281,7 +1394,7 @@
 </p:notes>
 </file>
 
-<file path=ppt/notesSlides/notesSlide18.xml><?xml version="1.0" encoding="utf-8"?>
+<file path=ppt/notesSlides/notesSlide19.xml><?xml version="1.0" encoding="utf-8"?>
 <p:notes xmlns:a="http://schemas.openxmlformats.org/drawingml/2006/main" xmlns:r="http://schemas.openxmlformats.org/officeDocument/2006/relationships" xmlns:p="http://schemas.openxmlformats.org/presentationml/2006/main">
   <p:cSld>
     <p:spTree>
@@ -1365,7 +1478,94 @@
 </p:notes>
 </file>
 
-<file path=ppt/notesSlides/notesSlide19.xml><?xml version="1.0" encoding="utf-8"?>
+<file path=ppt/notesSlides/notesSlide2.xml><?xml version="1.0" encoding="utf-8"?>
+<p:notes xmlns:a="http://schemas.openxmlformats.org/drawingml/2006/main" xmlns:r="http://schemas.openxmlformats.org/officeDocument/2006/relationships" xmlns:p="http://schemas.openxmlformats.org/presentationml/2006/main">
+  <p:cSld>
+    <p:spTree>
+      <p:nvGrpSpPr>
+        <p:cNvPr id="1" name=""/>
+        <p:cNvGrpSpPr/>
+        <p:nvPr/>
+      </p:nvGrpSpPr>
+      <p:grpSpPr>
+        <a:xfrm>
+          <a:off x="0" y="0"/>
+          <a:ext cx="0" cy="0"/>
+          <a:chOff x="0" y="0"/>
+          <a:chExt cx="0" cy="0"/>
+        </a:xfrm>
+      </p:grpSpPr>
+      <p:sp>
+        <p:nvSpPr>
+          <p:cNvPr id="2" name="Slide Image Placeholder 1"/>
+          <p:cNvSpPr>
+            <a:spLocks noGrp="1" noRot="1" noChangeAspect="1"/>
+          </p:cNvSpPr>
+          <p:nvPr>
+            <p:ph type="sldImg"/>
+          </p:nvPr>
+        </p:nvSpPr>
+        <p:spPr/>
+      </p:sp>
+      <p:sp>
+        <p:nvSpPr>
+          <p:cNvPr id="3" name="Notes Placeholder 2"/>
+          <p:cNvSpPr>
+            <a:spLocks noGrp="1"/>
+          </p:cNvSpPr>
+          <p:nvPr>
+            <p:ph type="body" idx="1"/>
+          </p:nvPr>
+        </p:nvSpPr>
+        <p:spPr/>
+        <p:txBody>
+          <a:bodyPr/>
+          <a:lstStyle/>
+          <a:p>
+            <a:r>
+              <a:rPr lang="en-US" dirty="0"/>
+              <a:t>If d’ and d’’ has the considerable probability to generate y, then y is able to be released</a:t>
+            </a:r>
+          </a:p>
+        </p:txBody>
+      </p:sp>
+      <p:sp>
+        <p:nvSpPr>
+          <p:cNvPr id="4" name="Slide Number Placeholder 3"/>
+          <p:cNvSpPr>
+            <a:spLocks noGrp="1"/>
+          </p:cNvSpPr>
+          <p:nvPr>
+            <p:ph type="sldNum" sz="quarter" idx="5"/>
+          </p:nvPr>
+        </p:nvSpPr>
+        <p:spPr/>
+        <p:txBody>
+          <a:bodyPr/>
+          <a:lstStyle/>
+          <a:p>
+            <a:fld id="{EAE826E6-07E3-4CA6-BA08-B9A6E0BDBC70}" type="slidenum">
+              <a:rPr lang="en-US" smtClean="0"/>
+              <a:t>5</a:t>
+            </a:fld>
+            <a:endParaRPr lang="en-US"/>
+          </a:p>
+        </p:txBody>
+      </p:sp>
+    </p:spTree>
+    <p:extLst>
+      <p:ext uri="{BB962C8B-B14F-4D97-AF65-F5344CB8AC3E}">
+        <p14:creationId xmlns:p14="http://schemas.microsoft.com/office/powerpoint/2010/main" val="4112837543"/>
+      </p:ext>
+    </p:extLst>
+  </p:cSld>
+  <p:clrMapOvr>
+    <a:masterClrMapping/>
+  </p:clrMapOvr>
+</p:notes>
+</file>
+
+<file path=ppt/notesSlides/notesSlide20.xml><?xml version="1.0" encoding="utf-8"?>
 <p:notes xmlns:a="http://schemas.openxmlformats.org/drawingml/2006/main" xmlns:r="http://schemas.openxmlformats.org/officeDocument/2006/relationships" xmlns:p="http://schemas.openxmlformats.org/presentationml/2006/main">
   <p:cSld>
     <p:spTree>
@@ -1449,174 +1649,6 @@
 </p:notes>
 </file>
 
-<file path=ppt/notesSlides/notesSlide2.xml><?xml version="1.0" encoding="utf-8"?>
-<p:notes xmlns:a="http://schemas.openxmlformats.org/drawingml/2006/main" xmlns:r="http://schemas.openxmlformats.org/officeDocument/2006/relationships" xmlns:p="http://schemas.openxmlformats.org/presentationml/2006/main">
-  <p:cSld>
-    <p:spTree>
-      <p:nvGrpSpPr>
-        <p:cNvPr id="1" name=""/>
-        <p:cNvGrpSpPr/>
-        <p:nvPr/>
-      </p:nvGrpSpPr>
-      <p:grpSpPr>
-        <a:xfrm>
-          <a:off x="0" y="0"/>
-          <a:ext cx="0" cy="0"/>
-          <a:chOff x="0" y="0"/>
-          <a:chExt cx="0" cy="0"/>
-        </a:xfrm>
-      </p:grpSpPr>
-      <p:sp>
-        <p:nvSpPr>
-          <p:cNvPr id="2" name="Slide Image Placeholder 1"/>
-          <p:cNvSpPr>
-            <a:spLocks noGrp="1" noRot="1" noChangeAspect="1"/>
-          </p:cNvSpPr>
-          <p:nvPr>
-            <p:ph type="sldImg"/>
-          </p:nvPr>
-        </p:nvSpPr>
-        <p:spPr/>
-      </p:sp>
-      <p:sp>
-        <p:nvSpPr>
-          <p:cNvPr id="3" name="Notes Placeholder 2"/>
-          <p:cNvSpPr>
-            <a:spLocks noGrp="1"/>
-          </p:cNvSpPr>
-          <p:nvPr>
-            <p:ph type="body" idx="1"/>
-          </p:nvPr>
-        </p:nvSpPr>
-        <p:spPr/>
-        <p:txBody>
-          <a:bodyPr/>
-          <a:lstStyle/>
-          <a:p>
-            <a:endParaRPr lang="en-US" dirty="0"/>
-          </a:p>
-        </p:txBody>
-      </p:sp>
-      <p:sp>
-        <p:nvSpPr>
-          <p:cNvPr id="4" name="Slide Number Placeholder 3"/>
-          <p:cNvSpPr>
-            <a:spLocks noGrp="1"/>
-          </p:cNvSpPr>
-          <p:nvPr>
-            <p:ph type="sldNum" sz="quarter" idx="5"/>
-          </p:nvPr>
-        </p:nvSpPr>
-        <p:spPr/>
-        <p:txBody>
-          <a:bodyPr/>
-          <a:lstStyle/>
-          <a:p>
-            <a:fld id="{EAE826E6-07E3-4CA6-BA08-B9A6E0BDBC70}" type="slidenum">
-              <a:rPr lang="en-US" smtClean="0"/>
-              <a:t>6</a:t>
-            </a:fld>
-            <a:endParaRPr lang="en-US"/>
-          </a:p>
-        </p:txBody>
-      </p:sp>
-    </p:spTree>
-    <p:extLst>
-      <p:ext uri="{BB962C8B-B14F-4D97-AF65-F5344CB8AC3E}">
-        <p14:creationId xmlns:p14="http://schemas.microsoft.com/office/powerpoint/2010/main" val="4115517419"/>
-      </p:ext>
-    </p:extLst>
-  </p:cSld>
-  <p:clrMapOvr>
-    <a:masterClrMapping/>
-  </p:clrMapOvr>
-</p:notes>
-</file>
-
-<file path=ppt/notesSlides/notesSlide20.xml><?xml version="1.0" encoding="utf-8"?>
-<p:notes xmlns:a="http://schemas.openxmlformats.org/drawingml/2006/main" xmlns:r="http://schemas.openxmlformats.org/officeDocument/2006/relationships" xmlns:p="http://schemas.openxmlformats.org/presentationml/2006/main">
-  <p:cSld>
-    <p:spTree>
-      <p:nvGrpSpPr>
-        <p:cNvPr id="1" name=""/>
-        <p:cNvGrpSpPr/>
-        <p:nvPr/>
-      </p:nvGrpSpPr>
-      <p:grpSpPr>
-        <a:xfrm>
-          <a:off x="0" y="0"/>
-          <a:ext cx="0" cy="0"/>
-          <a:chOff x="0" y="0"/>
-          <a:chExt cx="0" cy="0"/>
-        </a:xfrm>
-      </p:grpSpPr>
-      <p:sp>
-        <p:nvSpPr>
-          <p:cNvPr id="2" name="Slide Image Placeholder 1"/>
-          <p:cNvSpPr>
-            <a:spLocks noGrp="1" noRot="1" noChangeAspect="1"/>
-          </p:cNvSpPr>
-          <p:nvPr>
-            <p:ph type="sldImg"/>
-          </p:nvPr>
-        </p:nvSpPr>
-        <p:spPr/>
-      </p:sp>
-      <p:sp>
-        <p:nvSpPr>
-          <p:cNvPr id="3" name="Notes Placeholder 2"/>
-          <p:cNvSpPr>
-            <a:spLocks noGrp="1"/>
-          </p:cNvSpPr>
-          <p:nvPr>
-            <p:ph type="body" idx="1"/>
-          </p:nvPr>
-        </p:nvSpPr>
-        <p:spPr/>
-        <p:txBody>
-          <a:bodyPr/>
-          <a:lstStyle/>
-          <a:p>
-            <a:endParaRPr lang="en-US" dirty="0"/>
-          </a:p>
-        </p:txBody>
-      </p:sp>
-      <p:sp>
-        <p:nvSpPr>
-          <p:cNvPr id="4" name="Slide Number Placeholder 3"/>
-          <p:cNvSpPr>
-            <a:spLocks noGrp="1"/>
-          </p:cNvSpPr>
-          <p:nvPr>
-            <p:ph type="sldNum" sz="quarter" idx="5"/>
-          </p:nvPr>
-        </p:nvSpPr>
-        <p:spPr/>
-        <p:txBody>
-          <a:bodyPr/>
-          <a:lstStyle/>
-          <a:p>
-            <a:fld id="{EAE826E6-07E3-4CA6-BA08-B9A6E0BDBC70}" type="slidenum">
-              <a:rPr lang="en-US" smtClean="0"/>
-              <a:t>25</a:t>
-            </a:fld>
-            <a:endParaRPr lang="en-US"/>
-          </a:p>
-        </p:txBody>
-      </p:sp>
-    </p:spTree>
-    <p:extLst>
-      <p:ext uri="{BB962C8B-B14F-4D97-AF65-F5344CB8AC3E}">
-        <p14:creationId xmlns:p14="http://schemas.microsoft.com/office/powerpoint/2010/main" val="1525504048"/>
-      </p:ext>
-    </p:extLst>
-  </p:cSld>
-  <p:clrMapOvr>
-    <a:masterClrMapping/>
-  </p:clrMapOvr>
-</p:notes>
-</file>
-
 <file path=ppt/notesSlides/notesSlide21.xml><?xml version="1.0" encoding="utf-8"?>
 <p:notes xmlns:a="http://schemas.openxmlformats.org/drawingml/2006/main" xmlns:r="http://schemas.openxmlformats.org/officeDocument/2006/relationships" xmlns:p="http://schemas.openxmlformats.org/presentationml/2006/main">
   <p:cSld>
@@ -1661,7 +1693,105 @@
           <a:bodyPr/>
           <a:lstStyle/>
           <a:p>
-            <a:endParaRPr lang="en-US" dirty="0"/>
+            <a:r>
+              <a:rPr lang="en-US" dirty="0"/>
+              <a:t>Number of votes on the </a:t>
+            </a:r>
+            <a:r>
+              <a:rPr lang="en-US" dirty="0" err="1"/>
+              <a:t>ith</a:t>
+            </a:r>
+            <a:r>
+              <a:rPr lang="en-US" dirty="0"/>
+              <a:t> class</a:t>
+            </a:r>
+          </a:p>
+        </p:txBody>
+      </p:sp>
+      <p:sp>
+        <p:nvSpPr>
+          <p:cNvPr id="4" name="Slide Number Placeholder 3"/>
+          <p:cNvSpPr>
+            <a:spLocks noGrp="1"/>
+          </p:cNvSpPr>
+          <p:nvPr>
+            <p:ph type="sldNum" sz="quarter" idx="5"/>
+          </p:nvPr>
+        </p:nvSpPr>
+        <p:spPr/>
+        <p:txBody>
+          <a:bodyPr/>
+          <a:lstStyle/>
+          <a:p>
+            <a:fld id="{EAE826E6-07E3-4CA6-BA08-B9A6E0BDBC70}" type="slidenum">
+              <a:rPr lang="en-US" smtClean="0"/>
+              <a:t>25</a:t>
+            </a:fld>
+            <a:endParaRPr lang="en-US"/>
+          </a:p>
+        </p:txBody>
+      </p:sp>
+    </p:spTree>
+    <p:extLst>
+      <p:ext uri="{BB962C8B-B14F-4D97-AF65-F5344CB8AC3E}">
+        <p14:creationId xmlns:p14="http://schemas.microsoft.com/office/powerpoint/2010/main" val="1525504048"/>
+      </p:ext>
+    </p:extLst>
+  </p:cSld>
+  <p:clrMapOvr>
+    <a:masterClrMapping/>
+  </p:clrMapOvr>
+</p:notes>
+</file>
+
+<file path=ppt/notesSlides/notesSlide22.xml><?xml version="1.0" encoding="utf-8"?>
+<p:notes xmlns:a="http://schemas.openxmlformats.org/drawingml/2006/main" xmlns:r="http://schemas.openxmlformats.org/officeDocument/2006/relationships" xmlns:p="http://schemas.openxmlformats.org/presentationml/2006/main">
+  <p:cSld>
+    <p:spTree>
+      <p:nvGrpSpPr>
+        <p:cNvPr id="1" name=""/>
+        <p:cNvGrpSpPr/>
+        <p:nvPr/>
+      </p:nvGrpSpPr>
+      <p:grpSpPr>
+        <a:xfrm>
+          <a:off x="0" y="0"/>
+          <a:ext cx="0" cy="0"/>
+          <a:chOff x="0" y="0"/>
+          <a:chExt cx="0" cy="0"/>
+        </a:xfrm>
+      </p:grpSpPr>
+      <p:sp>
+        <p:nvSpPr>
+          <p:cNvPr id="2" name="Slide Image Placeholder 1"/>
+          <p:cNvSpPr>
+            <a:spLocks noGrp="1" noRot="1" noChangeAspect="1"/>
+          </p:cNvSpPr>
+          <p:nvPr>
+            <p:ph type="sldImg"/>
+          </p:nvPr>
+        </p:nvSpPr>
+        <p:spPr/>
+      </p:sp>
+      <p:sp>
+        <p:nvSpPr>
+          <p:cNvPr id="3" name="Notes Placeholder 2"/>
+          <p:cNvSpPr>
+            <a:spLocks noGrp="1"/>
+          </p:cNvSpPr>
+          <p:nvPr>
+            <p:ph type="body" idx="1"/>
+          </p:nvPr>
+        </p:nvSpPr>
+        <p:spPr/>
+        <p:txBody>
+          <a:bodyPr/>
+          <a:lstStyle/>
+          <a:p>
+            <a:r>
+              <a:rPr lang="en-US" dirty="0"/>
+              <a:t>which means a certain number of teachers agree on this answer, the adversary can not trace back who is the teacher gives the answer.</a:t>
+            </a:r>
           </a:p>
         </p:txBody>
       </p:sp>
@@ -1701,7 +1831,7 @@
 </p:notes>
 </file>
 
-<file path=ppt/notesSlides/notesSlide22.xml><?xml version="1.0" encoding="utf-8"?>
+<file path=ppt/notesSlides/notesSlide23.xml><?xml version="1.0" encoding="utf-8"?>
 <p:notes xmlns:a="http://schemas.openxmlformats.org/drawingml/2006/main" xmlns:r="http://schemas.openxmlformats.org/officeDocument/2006/relationships" xmlns:p="http://schemas.openxmlformats.org/presentationml/2006/main">
   <p:cSld>
     <p:spTree>
@@ -1785,7 +1915,7 @@
 </p:notes>
 </file>
 
-<file path=ppt/notesSlides/notesSlide23.xml><?xml version="1.0" encoding="utf-8"?>
+<file path=ppt/notesSlides/notesSlide24.xml><?xml version="1.0" encoding="utf-8"?>
 <p:notes xmlns:a="http://schemas.openxmlformats.org/drawingml/2006/main" xmlns:r="http://schemas.openxmlformats.org/officeDocument/2006/relationships" xmlns:p="http://schemas.openxmlformats.org/presentationml/2006/main">
   <p:cSld>
     <p:spTree>
@@ -1829,7 +1959,10 @@
           <a:bodyPr/>
           <a:lstStyle/>
           <a:p>
-            <a:endParaRPr lang="en-US" dirty="0"/>
+            <a:r>
+              <a:rPr lang="en-US" dirty="0"/>
+              <a:t>Achieve comparable accuracy but save the privacy cost</a:t>
+            </a:r>
           </a:p>
         </p:txBody>
       </p:sp>
@@ -1934,6 +2067,90 @@
           <a:p>
             <a:fld id="{EAE826E6-07E3-4CA6-BA08-B9A6E0BDBC70}" type="slidenum">
               <a:rPr lang="en-US" smtClean="0"/>
+              <a:t>6</a:t>
+            </a:fld>
+            <a:endParaRPr lang="en-US"/>
+          </a:p>
+        </p:txBody>
+      </p:sp>
+    </p:spTree>
+    <p:extLst>
+      <p:ext uri="{BB962C8B-B14F-4D97-AF65-F5344CB8AC3E}">
+        <p14:creationId xmlns:p14="http://schemas.microsoft.com/office/powerpoint/2010/main" val="4115517419"/>
+      </p:ext>
+    </p:extLst>
+  </p:cSld>
+  <p:clrMapOvr>
+    <a:masterClrMapping/>
+  </p:clrMapOvr>
+</p:notes>
+</file>
+
+<file path=ppt/notesSlides/notesSlide4.xml><?xml version="1.0" encoding="utf-8"?>
+<p:notes xmlns:a="http://schemas.openxmlformats.org/drawingml/2006/main" xmlns:r="http://schemas.openxmlformats.org/officeDocument/2006/relationships" xmlns:p="http://schemas.openxmlformats.org/presentationml/2006/main">
+  <p:cSld>
+    <p:spTree>
+      <p:nvGrpSpPr>
+        <p:cNvPr id="1" name=""/>
+        <p:cNvGrpSpPr/>
+        <p:nvPr/>
+      </p:nvGrpSpPr>
+      <p:grpSpPr>
+        <a:xfrm>
+          <a:off x="0" y="0"/>
+          <a:ext cx="0" cy="0"/>
+          <a:chOff x="0" y="0"/>
+          <a:chExt cx="0" cy="0"/>
+        </a:xfrm>
+      </p:grpSpPr>
+      <p:sp>
+        <p:nvSpPr>
+          <p:cNvPr id="2" name="Slide Image Placeholder 1"/>
+          <p:cNvSpPr>
+            <a:spLocks noGrp="1" noRot="1" noChangeAspect="1"/>
+          </p:cNvSpPr>
+          <p:nvPr>
+            <p:ph type="sldImg"/>
+          </p:nvPr>
+        </p:nvSpPr>
+        <p:spPr/>
+      </p:sp>
+      <p:sp>
+        <p:nvSpPr>
+          <p:cNvPr id="3" name="Notes Placeholder 2"/>
+          <p:cNvSpPr>
+            <a:spLocks noGrp="1"/>
+          </p:cNvSpPr>
+          <p:nvPr>
+            <p:ph type="body" idx="1"/>
+          </p:nvPr>
+        </p:nvSpPr>
+        <p:spPr/>
+        <p:txBody>
+          <a:bodyPr/>
+          <a:lstStyle/>
+          <a:p>
+            <a:endParaRPr lang="en-US" dirty="0"/>
+          </a:p>
+        </p:txBody>
+      </p:sp>
+      <p:sp>
+        <p:nvSpPr>
+          <p:cNvPr id="4" name="Slide Number Placeholder 3"/>
+          <p:cNvSpPr>
+            <a:spLocks noGrp="1"/>
+          </p:cNvSpPr>
+          <p:nvPr>
+            <p:ph type="sldNum" sz="quarter" idx="5"/>
+          </p:nvPr>
+        </p:nvSpPr>
+        <p:spPr/>
+        <p:txBody>
+          <a:bodyPr/>
+          <a:lstStyle/>
+          <a:p>
+            <a:fld id="{EAE826E6-07E3-4CA6-BA08-B9A6E0BDBC70}" type="slidenum">
+              <a:rPr lang="en-US" smtClean="0"/>
               <a:t>7</a:t>
             </a:fld>
             <a:endParaRPr lang="en-US"/>
@@ -1953,7 +2170,7 @@
 </p:notes>
 </file>
 
-<file path=ppt/notesSlides/notesSlide4.xml><?xml version="1.0" encoding="utf-8"?>
+<file path=ppt/notesSlides/notesSlide5.xml><?xml version="1.0" encoding="utf-8"?>
 <p:notes xmlns:a="http://schemas.openxmlformats.org/drawingml/2006/main" xmlns:r="http://schemas.openxmlformats.org/officeDocument/2006/relationships" xmlns:p="http://schemas.openxmlformats.org/presentationml/2006/main">
   <p:cSld>
     <p:spTree>
@@ -2037,7 +2254,7 @@
 </p:notes>
 </file>
 
-<file path=ppt/notesSlides/notesSlide5.xml><?xml version="1.0" encoding="utf-8"?>
+<file path=ppt/notesSlides/notesSlide6.xml><?xml version="1.0" encoding="utf-8"?>
 <p:notes xmlns:a="http://schemas.openxmlformats.org/drawingml/2006/main" xmlns:r="http://schemas.openxmlformats.org/officeDocument/2006/relationships" xmlns:p="http://schemas.openxmlformats.org/presentationml/2006/main">
   <p:cSld>
     <p:spTree>
@@ -2121,7 +2338,7 @@
 </p:notes>
 </file>
 
-<file path=ppt/notesSlides/notesSlide6.xml><?xml version="1.0" encoding="utf-8"?>
+<file path=ppt/notesSlides/notesSlide7.xml><?xml version="1.0" encoding="utf-8"?>
 <p:notes xmlns:a="http://schemas.openxmlformats.org/drawingml/2006/main" xmlns:r="http://schemas.openxmlformats.org/officeDocument/2006/relationships" xmlns:p="http://schemas.openxmlformats.org/presentationml/2006/main">
   <p:cSld>
     <p:spTree>
@@ -2205,7 +2422,7 @@
 </p:notes>
 </file>
 
-<file path=ppt/notesSlides/notesSlide7.xml><?xml version="1.0" encoding="utf-8"?>
+<file path=ppt/notesSlides/notesSlide8.xml><?xml version="1.0" encoding="utf-8"?>
 <p:notes xmlns:a="http://schemas.openxmlformats.org/drawingml/2006/main" xmlns:r="http://schemas.openxmlformats.org/officeDocument/2006/relationships" xmlns:p="http://schemas.openxmlformats.org/presentationml/2006/main">
   <p:cSld>
     <p:spTree>
@@ -2289,7 +2506,7 @@
 </p:notes>
 </file>
 
-<file path=ppt/notesSlides/notesSlide8.xml><?xml version="1.0" encoding="utf-8"?>
+<file path=ppt/notesSlides/notesSlide9.xml><?xml version="1.0" encoding="utf-8"?>
 <p:notes xmlns:a="http://schemas.openxmlformats.org/drawingml/2006/main" xmlns:r="http://schemas.openxmlformats.org/officeDocument/2006/relationships" xmlns:p="http://schemas.openxmlformats.org/presentationml/2006/main">
   <p:cSld>
     <p:spTree>
@@ -2364,90 +2581,6 @@
     <p:extLst>
       <p:ext uri="{BB962C8B-B14F-4D97-AF65-F5344CB8AC3E}">
         <p14:creationId xmlns:p14="http://schemas.microsoft.com/office/powerpoint/2010/main" val="3633102517"/>
-      </p:ext>
-    </p:extLst>
-  </p:cSld>
-  <p:clrMapOvr>
-    <a:masterClrMapping/>
-  </p:clrMapOvr>
-</p:notes>
-</file>
-
-<file path=ppt/notesSlides/notesSlide9.xml><?xml version="1.0" encoding="utf-8"?>
-<p:notes xmlns:a="http://schemas.openxmlformats.org/drawingml/2006/main" xmlns:r="http://schemas.openxmlformats.org/officeDocument/2006/relationships" xmlns:p="http://schemas.openxmlformats.org/presentationml/2006/main">
-  <p:cSld>
-    <p:spTree>
-      <p:nvGrpSpPr>
-        <p:cNvPr id="1" name=""/>
-        <p:cNvGrpSpPr/>
-        <p:nvPr/>
-      </p:nvGrpSpPr>
-      <p:grpSpPr>
-        <a:xfrm>
-          <a:off x="0" y="0"/>
-          <a:ext cx="0" cy="0"/>
-          <a:chOff x="0" y="0"/>
-          <a:chExt cx="0" cy="0"/>
-        </a:xfrm>
-      </p:grpSpPr>
-      <p:sp>
-        <p:nvSpPr>
-          <p:cNvPr id="2" name="Slide Image Placeholder 1"/>
-          <p:cNvSpPr>
-            <a:spLocks noGrp="1" noRot="1" noChangeAspect="1"/>
-          </p:cNvSpPr>
-          <p:nvPr>
-            <p:ph type="sldImg"/>
-          </p:nvPr>
-        </p:nvSpPr>
-        <p:spPr/>
-      </p:sp>
-      <p:sp>
-        <p:nvSpPr>
-          <p:cNvPr id="3" name="Notes Placeholder 2"/>
-          <p:cNvSpPr>
-            <a:spLocks noGrp="1"/>
-          </p:cNvSpPr>
-          <p:nvPr>
-            <p:ph type="body" idx="1"/>
-          </p:nvPr>
-        </p:nvSpPr>
-        <p:spPr/>
-        <p:txBody>
-          <a:bodyPr/>
-          <a:lstStyle/>
-          <a:p>
-            <a:endParaRPr lang="en-US" dirty="0"/>
-          </a:p>
-        </p:txBody>
-      </p:sp>
-      <p:sp>
-        <p:nvSpPr>
-          <p:cNvPr id="4" name="Slide Number Placeholder 3"/>
-          <p:cNvSpPr>
-            <a:spLocks noGrp="1"/>
-          </p:cNvSpPr>
-          <p:nvPr>
-            <p:ph type="sldNum" sz="quarter" idx="5"/>
-          </p:nvPr>
-        </p:nvSpPr>
-        <p:spPr/>
-        <p:txBody>
-          <a:bodyPr/>
-          <a:lstStyle/>
-          <a:p>
-            <a:fld id="{EAE826E6-07E3-4CA6-BA08-B9A6E0BDBC70}" type="slidenum">
-              <a:rPr lang="en-US" smtClean="0"/>
-              <a:t>13</a:t>
-            </a:fld>
-            <a:endParaRPr lang="en-US"/>
-          </a:p>
-        </p:txBody>
-      </p:sp>
-    </p:spTree>
-    <p:extLst>
-      <p:ext uri="{BB962C8B-B14F-4D97-AF65-F5344CB8AC3E}">
-        <p14:creationId xmlns:p14="http://schemas.microsoft.com/office/powerpoint/2010/main" val="3489210885"/>
       </p:ext>
     </p:extLst>
   </p:cSld>
@@ -6273,8 +6406,8 @@
           </a:p>
         </p:txBody>
       </p:sp>
-      <mc:AlternateContent xmlns:mc="http://schemas.openxmlformats.org/markup-compatibility/2006">
-        <mc:Choice xmlns:a14="http://schemas.microsoft.com/office/drawing/2010/main" Requires="a14">
+      <mc:AlternateContent xmlns:mc="http://schemas.openxmlformats.org/markup-compatibility/2006" xmlns:a14="http://schemas.microsoft.com/office/drawing/2010/main">
+        <mc:Choice Requires="a14">
           <p:sp>
             <p:nvSpPr>
               <p:cNvPr id="3" name="Rectangle 2">
@@ -6290,7 +6423,7 @@
             <p:spPr>
               <a:xfrm>
                 <a:off x="380999" y="2434923"/>
-                <a:ext cx="7955133" cy="1780616"/>
+                <a:ext cx="7955133" cy="2057615"/>
               </a:xfrm>
               <a:prstGeom prst="rect">
                 <a:avLst/>
@@ -6481,7 +6614,31 @@
                     <a:latin typeface="Calibri" charset="0"/>
                     <a:cs typeface="Calibri" charset="0"/>
                   </a:rPr>
-                  <a:t>} be the set of random variables associated with the attributes of the data records in </a:t>
+                  <a:t>} be the set of random variables associated with the attributes of the data record </a:t>
+                </a:r>
+                <a14:m>
+                  <m:oMath xmlns:m="http://schemas.openxmlformats.org/officeDocument/2006/math">
+                    <m:r>
+                      <a:rPr lang="en-US" altLang="zh-CN" i="1" dirty="0" smtClean="0">
+                        <a:solidFill>
+                          <a:srgbClr val="13294B"/>
+                        </a:solidFill>
+                        <a:latin typeface="Cambria Math" panose="02040503050406030204" pitchFamily="18" charset="0"/>
+                        <a:cs typeface="Calibri" charset="0"/>
+                      </a:rPr>
+                      <m:t>𝑑</m:t>
+                    </m:r>
+                  </m:oMath>
+                </a14:m>
+                <a:r>
+                  <a:rPr lang="en-US" dirty="0">
+                    <a:solidFill>
+                      <a:srgbClr val="13294B"/>
+                    </a:solidFill>
+                    <a:latin typeface="Calibri" charset="0"/>
+                    <a:cs typeface="Calibri" charset="0"/>
+                  </a:rPr>
+                  <a:t> in </a:t>
                 </a:r>
                 <a14:m>
                   <m:oMath xmlns:m="http://schemas.openxmlformats.org/officeDocument/2006/math">
@@ -6507,6 +6664,15 @@
                   </a:rPr>
                   <a:t>.</a:t>
                 </a:r>
+              </a:p>
+              <a:p>
+                <a:endParaRPr lang="en-US" dirty="0">
+                  <a:solidFill>
+                    <a:srgbClr val="13294B"/>
+                  </a:solidFill>
+                  <a:latin typeface="Calibri" charset="0"/>
+                  <a:cs typeface="Calibri" charset="0"/>
+                </a:endParaRPr>
               </a:p>
               <a:p>
                 <a:endParaRPr lang="en-US" dirty="0">
@@ -6704,7 +6870,7 @@
             </p:txBody>
           </p:sp>
         </mc:Choice>
-        <mc:Fallback>
+        <mc:Fallback xmlns="">
           <p:sp>
             <p:nvSpPr>
               <p:cNvPr id="3" name="Rectangle 2">
@@ -6722,7 +6888,7 @@
             <p:spPr>
               <a:xfrm>
                 <a:off x="380999" y="2434923"/>
-                <a:ext cx="7955133" cy="1780616"/>
+                <a:ext cx="7955133" cy="2057615"/>
               </a:xfrm>
               <a:prstGeom prst="rect">
                 <a:avLst/>
@@ -6730,7 +6896,7 @@
               <a:blipFill>
                 <a:blip r:embed="rId3"/>
                 <a:stretch>
-                  <a:fillRect l="-613" t="-1706" b="-4096"/>
+                  <a:fillRect l="-613" t="-1479" b="-3550"/>
                 </a:stretch>
               </a:blipFill>
             </p:spPr>
@@ -7137,8 +7303,8 @@
               </a:prstGeom>
             </p:spPr>
           </p:pic>
-          <mc:AlternateContent xmlns:mc="http://schemas.openxmlformats.org/markup-compatibility/2006">
-            <mc:Choice xmlns:a14="http://schemas.microsoft.com/office/drawing/2010/main" Requires="a14">
+          <mc:AlternateContent xmlns:mc="http://schemas.openxmlformats.org/markup-compatibility/2006" xmlns:a14="http://schemas.microsoft.com/office/drawing/2010/main">
+            <mc:Choice Requires="a14">
               <p:sp>
                 <p:nvSpPr>
                   <p:cNvPr id="5" name="Rectangle 4">
@@ -7166,6 +7332,7 @@
                   </a:bodyPr>
                   <a:lstStyle/>
                   <a:p>
+                    <a:pPr/>
                     <a14:m>
                       <m:oMathPara xmlns:m="http://schemas.openxmlformats.org/officeDocument/2006/math">
                         <m:oMathParaPr>
@@ -7217,7 +7384,7 @@
                 </p:txBody>
               </p:sp>
             </mc:Choice>
-            <mc:Fallback>
+            <mc:Fallback xmlns="">
               <p:sp>
                 <p:nvSpPr>
                   <p:cNvPr id="5" name="Rectangle 4">
@@ -7262,8 +7429,8 @@
               </p:sp>
             </mc:Fallback>
           </mc:AlternateContent>
-          <mc:AlternateContent xmlns:mc="http://schemas.openxmlformats.org/markup-compatibility/2006">
-            <mc:Choice xmlns:a14="http://schemas.microsoft.com/office/drawing/2010/main" Requires="a14">
+          <mc:AlternateContent xmlns:mc="http://schemas.openxmlformats.org/markup-compatibility/2006" xmlns:a14="http://schemas.microsoft.com/office/drawing/2010/main">
+            <mc:Choice Requires="a14">
               <p:sp>
                 <p:nvSpPr>
                   <p:cNvPr id="6" name="Rectangle 5">
@@ -7291,6 +7458,7 @@
                   </a:bodyPr>
                   <a:lstStyle/>
                   <a:p>
+                    <a:pPr/>
                     <a14:m>
                       <m:oMathPara xmlns:m="http://schemas.openxmlformats.org/officeDocument/2006/math">
                         <m:oMathParaPr>
@@ -7342,7 +7510,7 @@
                 </p:txBody>
               </p:sp>
             </mc:Choice>
-            <mc:Fallback>
+            <mc:Fallback xmlns="">
               <p:sp>
                 <p:nvSpPr>
                   <p:cNvPr id="6" name="Rectangle 5">
@@ -7387,8 +7555,8 @@
               </p:sp>
             </mc:Fallback>
           </mc:AlternateContent>
-          <mc:AlternateContent xmlns:mc="http://schemas.openxmlformats.org/markup-compatibility/2006">
-            <mc:Choice xmlns:a14="http://schemas.microsoft.com/office/drawing/2010/main" Requires="a14">
+          <mc:AlternateContent xmlns:mc="http://schemas.openxmlformats.org/markup-compatibility/2006" xmlns:a14="http://schemas.microsoft.com/office/drawing/2010/main">
+            <mc:Choice Requires="a14">
               <p:sp>
                 <p:nvSpPr>
                   <p:cNvPr id="9" name="Rectangle 8">
@@ -7416,6 +7584,7 @@
                   </a:bodyPr>
                   <a:lstStyle/>
                   <a:p>
+                    <a:pPr/>
                     <a14:m>
                       <m:oMathPara xmlns:m="http://schemas.openxmlformats.org/officeDocument/2006/math">
                         <m:oMathParaPr>
@@ -7467,7 +7636,7 @@
                 </p:txBody>
               </p:sp>
             </mc:Choice>
-            <mc:Fallback>
+            <mc:Fallback xmlns="">
               <p:sp>
                 <p:nvSpPr>
                   <p:cNvPr id="9" name="Rectangle 8">
@@ -7514,6 +7683,158 @@
           </mc:AlternateContent>
         </p:grpSp>
       </p:grpSp>
+      <mc:AlternateContent xmlns:mc="http://schemas.openxmlformats.org/markup-compatibility/2006" xmlns:a14="http://schemas.microsoft.com/office/drawing/2010/main">
+        <mc:Choice Requires="a14">
+          <p:sp>
+            <p:nvSpPr>
+              <p:cNvPr id="21" name="Rectangle 20">
+                <a:extLst>
+                  <a:ext uri="{FF2B5EF4-FFF2-40B4-BE49-F238E27FC236}">
+                    <a16:creationId xmlns:a16="http://schemas.microsoft.com/office/drawing/2014/main" id="{A4673A77-DC65-42EF-B2F5-DE67267E243D}"/>
+                  </a:ext>
+                </a:extLst>
+              </p:cNvPr>
+              <p:cNvSpPr/>
+              <p:nvPr/>
+            </p:nvSpPr>
+            <p:spPr>
+              <a:xfrm>
+                <a:off x="393156" y="5237491"/>
+                <a:ext cx="4572000" cy="923330"/>
+              </a:xfrm>
+              <a:prstGeom prst="rect">
+                <a:avLst/>
+              </a:prstGeom>
+            </p:spPr>
+            <p:txBody>
+              <a:bodyPr>
+                <a:spAutoFit/>
+              </a:bodyPr>
+              <a:lstStyle/>
+              <a:p>
+                <a:r>
+                  <a:rPr lang="en-US" dirty="0">
+                    <a:solidFill>
+                      <a:srgbClr val="13294B"/>
+                    </a:solidFill>
+                    <a:latin typeface="Calibri" charset="0"/>
+                    <a:cs typeface="Calibri" charset="0"/>
+                  </a:rPr>
+                  <a:t>The model is based on a </a:t>
+                </a:r>
+                <a:r>
+                  <a:rPr lang="en-US" b="1" dirty="0">
+                    <a:solidFill>
+                      <a:srgbClr val="13294B"/>
+                    </a:solidFill>
+                    <a:latin typeface="Calibri" charset="0"/>
+                    <a:cs typeface="Calibri" charset="0"/>
+                  </a:rPr>
+                  <a:t>structure</a:t>
+                </a:r>
+                <a:r>
+                  <a:rPr lang="en-US" dirty="0">
+                    <a:solidFill>
+                      <a:srgbClr val="13294B"/>
+                    </a:solidFill>
+                    <a:latin typeface="Calibri" charset="0"/>
+                    <a:cs typeface="Calibri" charset="0"/>
+                  </a:rPr>
+                  <a:t> of </a:t>
+                </a:r>
+                <a14:m>
+                  <m:oMath xmlns:m="http://schemas.openxmlformats.org/officeDocument/2006/math">
+                    <m:r>
+                      <a:rPr lang="en-US" i="1" dirty="0" smtClean="0">
+                        <a:solidFill>
+                          <a:srgbClr val="13294B"/>
+                        </a:solidFill>
+                        <a:latin typeface="Cambria Math" panose="02040503050406030204" pitchFamily="18" charset="0"/>
+                        <a:cs typeface="Calibri" charset="0"/>
+                      </a:rPr>
+                      <m:t>𝐺</m:t>
+                    </m:r>
+                  </m:oMath>
+                </a14:m>
+                <a:r>
+                  <a:rPr lang="en-US" dirty="0">
+                    <a:solidFill>
+                      <a:srgbClr val="13294B"/>
+                    </a:solidFill>
+                    <a:latin typeface="Calibri" charset="0"/>
+                    <a:cs typeface="Calibri" charset="0"/>
+                  </a:rPr>
+                  <a:t>, and a set of </a:t>
+                </a:r>
+                <a:r>
+                  <a:rPr lang="en-US" b="1" dirty="0">
+                    <a:solidFill>
+                      <a:srgbClr val="13294B"/>
+                    </a:solidFill>
+                    <a:latin typeface="Calibri" charset="0"/>
+                    <a:cs typeface="Calibri" charset="0"/>
+                  </a:rPr>
+                  <a:t>parameters</a:t>
+                </a:r>
+                <a:r>
+                  <a:rPr lang="en-US" dirty="0">
+                    <a:solidFill>
+                      <a:srgbClr val="13294B"/>
+                    </a:solidFill>
+                    <a:latin typeface="Calibri" charset="0"/>
+                    <a:cs typeface="Calibri" charset="0"/>
+                  </a:rPr>
+                  <a:t> that constructs the conditional probabilities.</a:t>
+                </a:r>
+              </a:p>
+            </p:txBody>
+          </p:sp>
+        </mc:Choice>
+        <mc:Fallback xmlns="">
+          <p:sp>
+            <p:nvSpPr>
+              <p:cNvPr id="21" name="Rectangle 20">
+                <a:extLst>
+                  <a:ext uri="{FF2B5EF4-FFF2-40B4-BE49-F238E27FC236}">
+                    <a16:creationId xmlns:a16="http://schemas.microsoft.com/office/drawing/2014/main" id="{A4673A77-DC65-42EF-B2F5-DE67267E243D}"/>
+                  </a:ext>
+                </a:extLst>
+              </p:cNvPr>
+              <p:cNvSpPr>
+                <a:spLocks noRot="1" noChangeAspect="1" noMove="1" noResize="1" noEditPoints="1" noAdjustHandles="1" noChangeArrowheads="1" noChangeShapeType="1" noTextEdit="1"/>
+              </p:cNvSpPr>
+              <p:nvPr/>
+            </p:nvSpPr>
+            <p:spPr>
+              <a:xfrm>
+                <a:off x="393156" y="5237491"/>
+                <a:ext cx="4572000" cy="923330"/>
+              </a:xfrm>
+              <a:prstGeom prst="rect">
+                <a:avLst/>
+              </a:prstGeom>
+              <a:blipFill>
+                <a:blip r:embed="rId9"/>
+                <a:stretch>
+                  <a:fillRect l="-1067" t="-3289" b="-9211"/>
+                </a:stretch>
+              </a:blipFill>
+            </p:spPr>
+            <p:txBody>
+              <a:bodyPr/>
+              <a:lstStyle/>
+              <a:p>
+                <a:r>
+                  <a:rPr lang="en-US">
+                    <a:noFill/>
+                  </a:rPr>
+                  <a:t> </a:t>
+                </a:r>
+              </a:p>
+            </p:txBody>
+          </p:sp>
+        </mc:Fallback>
+      </mc:AlternateContent>
     </p:spTree>
     <p:extLst>
       <p:ext uri="{BB962C8B-B14F-4D97-AF65-F5344CB8AC3E}">
@@ -7693,8 +8014,8 @@
           </a:p>
         </p:txBody>
       </p:sp>
-      <mc:AlternateContent xmlns:mc="http://schemas.openxmlformats.org/markup-compatibility/2006">
-        <mc:Choice xmlns:a14="http://schemas.microsoft.com/office/drawing/2010/main" Requires="a14">
+      <mc:AlternateContent xmlns:mc="http://schemas.openxmlformats.org/markup-compatibility/2006" xmlns:a14="http://schemas.microsoft.com/office/drawing/2010/main">
+        <mc:Choice Requires="a14">
           <p:sp>
             <p:nvSpPr>
               <p:cNvPr id="3" name="Rectangle 2">
@@ -7710,7 +8031,7 @@
             <p:spPr>
               <a:xfrm>
                 <a:off x="380999" y="2434923"/>
-                <a:ext cx="7955133" cy="1200329"/>
+                <a:ext cx="7955133" cy="1477328"/>
               </a:xfrm>
               <a:prstGeom prst="rect">
                 <a:avLst/>
@@ -7821,7 +8142,7 @@
                     <a:latin typeface="Calibri" charset="0"/>
                     <a:cs typeface="Calibri" charset="0"/>
                   </a:rPr>
-                  <a:t>be the set of parents od random variable </a:t>
+                  <a:t>be the set of parents of random variable </a:t>
                 </a:r>
                 <a14:m>
                   <m:oMath xmlns:m="http://schemas.openxmlformats.org/officeDocument/2006/math">
@@ -7882,6 +8203,15 @@
                 </a:endParaRPr>
               </a:p>
               <a:p>
+                <a:endParaRPr lang="en-US" dirty="0">
+                  <a:solidFill>
+                    <a:srgbClr val="13294B"/>
+                  </a:solidFill>
+                  <a:latin typeface="Calibri" charset="0"/>
+                  <a:cs typeface="Calibri" charset="0"/>
+                </a:endParaRPr>
+              </a:p>
+              <a:p>
                 <a:r>
                   <a:rPr lang="en-US" dirty="0">
                     <a:solidFill>
@@ -7890,13 +8220,33 @@
                     <a:latin typeface="Calibri" charset="0"/>
                     <a:cs typeface="Calibri" charset="0"/>
                   </a:rPr>
-                  <a:t>The model to generate synthetic data is written as the joint probability</a:t>
+                  <a:t>The model to </a:t>
+                </a:r>
+                <a:r>
+                  <a:rPr lang="en-US" b="1" dirty="0">
+                    <a:solidFill>
+                      <a:srgbClr val="13294B"/>
+                    </a:solidFill>
+                    <a:latin typeface="Calibri" charset="0"/>
+                    <a:cs typeface="Calibri" charset="0"/>
+                  </a:rPr>
+                  <a:t>generate synthetic data</a:t>
+                </a:r>
+                <a:r>
+                  <a:rPr lang="en-US" dirty="0">
+                    <a:solidFill>
+                      <a:srgbClr val="13294B"/>
+                    </a:solidFill>
+                    <a:latin typeface="Calibri" charset="0"/>
+                    <a:cs typeface="Calibri" charset="0"/>
+                  </a:rPr>
+                  <a:t> is written as the joint probability</a:t>
                 </a:r>
               </a:p>
             </p:txBody>
           </p:sp>
         </mc:Choice>
-        <mc:Fallback>
+        <mc:Fallback xmlns="">
           <p:sp>
             <p:nvSpPr>
               <p:cNvPr id="3" name="Rectangle 2">
@@ -7914,7 +8264,7 @@
             <p:spPr>
               <a:xfrm>
                 <a:off x="380999" y="2434923"/>
-                <a:ext cx="7955133" cy="1200329"/>
+                <a:ext cx="7955133" cy="1477328"/>
               </a:xfrm>
               <a:prstGeom prst="rect">
                 <a:avLst/>
@@ -7922,7 +8272,7 @@
               <a:blipFill>
                 <a:blip r:embed="rId3"/>
                 <a:stretch>
-                  <a:fillRect l="-613" t="-2538" b="-7107"/>
+                  <a:fillRect l="-613" t="-2058" b="-5350"/>
                 </a:stretch>
               </a:blipFill>
             </p:spPr>
@@ -7963,7 +8313,7 @@
         </p:blipFill>
         <p:spPr>
           <a:xfrm>
-            <a:off x="949992" y="3680851"/>
+            <a:off x="1008808" y="3893944"/>
             <a:ext cx="6125430" cy="971686"/>
           </a:xfrm>
           <a:prstGeom prst="rect">
@@ -7971,8 +8321,8 @@
           </a:prstGeom>
         </p:spPr>
       </p:pic>
-      <mc:AlternateContent xmlns:mc="http://schemas.openxmlformats.org/markup-compatibility/2006">
-        <mc:Choice xmlns:a14="http://schemas.microsoft.com/office/drawing/2010/main" Requires="a14">
+      <mc:AlternateContent xmlns:mc="http://schemas.openxmlformats.org/markup-compatibility/2006" xmlns:a14="http://schemas.microsoft.com/office/drawing/2010/main">
+        <mc:Choice Requires="a14">
           <p:sp>
             <p:nvSpPr>
               <p:cNvPr id="5" name="Rectangle 4">
@@ -7987,7 +8337,7 @@
             </p:nvSpPr>
             <p:spPr>
               <a:xfrm>
-                <a:off x="380999" y="4698136"/>
+                <a:off x="393156" y="5241267"/>
                 <a:ext cx="4572000" cy="923330"/>
               </a:xfrm>
               <a:prstGeom prst="rect">
@@ -8078,7 +8428,7 @@
             </p:txBody>
           </p:sp>
         </mc:Choice>
-        <mc:Fallback>
+        <mc:Fallback xmlns="">
           <p:sp>
             <p:nvSpPr>
               <p:cNvPr id="5" name="Rectangle 4">
@@ -8095,7 +8445,7 @@
             </p:nvSpPr>
             <p:spPr>
               <a:xfrm>
-                <a:off x="380999" y="4698136"/>
+                <a:off x="393156" y="5241267"/>
                 <a:ext cx="4572000" cy="923330"/>
               </a:xfrm>
               <a:prstGeom prst="rect">
@@ -8511,8 +8861,8 @@
               </a:prstGeom>
             </p:spPr>
           </p:pic>
-          <mc:AlternateContent xmlns:mc="http://schemas.openxmlformats.org/markup-compatibility/2006">
-            <mc:Choice xmlns:a14="http://schemas.microsoft.com/office/drawing/2010/main" Requires="a14">
+          <mc:AlternateContent xmlns:mc="http://schemas.openxmlformats.org/markup-compatibility/2006" xmlns:a14="http://schemas.microsoft.com/office/drawing/2010/main">
+            <mc:Choice Requires="a14">
               <p:sp>
                 <p:nvSpPr>
                   <p:cNvPr id="45" name="Rectangle 44">
@@ -8540,6 +8890,7 @@
                   </a:bodyPr>
                   <a:lstStyle/>
                   <a:p>
+                    <a:pPr/>
                     <a14:m>
                       <m:oMathPara xmlns:m="http://schemas.openxmlformats.org/officeDocument/2006/math">
                         <m:oMathParaPr>
@@ -8591,7 +8942,7 @@
                 </p:txBody>
               </p:sp>
             </mc:Choice>
-            <mc:Fallback>
+            <mc:Fallback xmlns="">
               <p:sp>
                 <p:nvSpPr>
                   <p:cNvPr id="45" name="Rectangle 44">
@@ -8636,8 +8987,8 @@
               </p:sp>
             </mc:Fallback>
           </mc:AlternateContent>
-          <mc:AlternateContent xmlns:mc="http://schemas.openxmlformats.org/markup-compatibility/2006">
-            <mc:Choice xmlns:a14="http://schemas.microsoft.com/office/drawing/2010/main" Requires="a14">
+          <mc:AlternateContent xmlns:mc="http://schemas.openxmlformats.org/markup-compatibility/2006" xmlns:a14="http://schemas.microsoft.com/office/drawing/2010/main">
+            <mc:Choice Requires="a14">
               <p:sp>
                 <p:nvSpPr>
                   <p:cNvPr id="46" name="Rectangle 45">
@@ -8665,6 +9016,7 @@
                   </a:bodyPr>
                   <a:lstStyle/>
                   <a:p>
+                    <a:pPr/>
                     <a14:m>
                       <m:oMathPara xmlns:m="http://schemas.openxmlformats.org/officeDocument/2006/math">
                         <m:oMathParaPr>
@@ -8716,7 +9068,7 @@
                 </p:txBody>
               </p:sp>
             </mc:Choice>
-            <mc:Fallback>
+            <mc:Fallback xmlns="">
               <p:sp>
                 <p:nvSpPr>
                   <p:cNvPr id="46" name="Rectangle 45">
@@ -8761,8 +9113,8 @@
               </p:sp>
             </mc:Fallback>
           </mc:AlternateContent>
-          <mc:AlternateContent xmlns:mc="http://schemas.openxmlformats.org/markup-compatibility/2006">
-            <mc:Choice xmlns:a14="http://schemas.microsoft.com/office/drawing/2010/main" Requires="a14">
+          <mc:AlternateContent xmlns:mc="http://schemas.openxmlformats.org/markup-compatibility/2006" xmlns:a14="http://schemas.microsoft.com/office/drawing/2010/main">
+            <mc:Choice Requires="a14">
               <p:sp>
                 <p:nvSpPr>
                   <p:cNvPr id="47" name="Rectangle 46">
@@ -8790,6 +9142,7 @@
                   </a:bodyPr>
                   <a:lstStyle/>
                   <a:p>
+                    <a:pPr/>
                     <a14:m>
                       <m:oMathPara xmlns:m="http://schemas.openxmlformats.org/officeDocument/2006/math">
                         <m:oMathParaPr>
@@ -8841,7 +9194,7 @@
                 </p:txBody>
               </p:sp>
             </mc:Choice>
-            <mc:Fallback>
+            <mc:Fallback xmlns="">
               <p:sp>
                 <p:nvSpPr>
                   <p:cNvPr id="47" name="Rectangle 46">
@@ -9448,8 +9801,8 @@
           </a:extLst>
         </p:spPr>
       </p:pic>
-      <mc:AlternateContent xmlns:mc="http://schemas.openxmlformats.org/markup-compatibility/2006">
-        <mc:Choice xmlns:a14="http://schemas.microsoft.com/office/drawing/2010/main" Requires="a14">
+      <mc:AlternateContent xmlns:mc="http://schemas.openxmlformats.org/markup-compatibility/2006" xmlns:a14="http://schemas.microsoft.com/office/drawing/2010/main">
+        <mc:Choice Requires="a14">
           <p:sp>
             <p:nvSpPr>
               <p:cNvPr id="13" name="Content Placeholder 2">
@@ -9668,7 +10021,7 @@
             </p:txBody>
           </p:sp>
         </mc:Choice>
-        <mc:Fallback>
+        <mc:Fallback xmlns="">
           <p:sp>
             <p:nvSpPr>
               <p:cNvPr id="13" name="Content Placeholder 2">
@@ -9713,8 +10066,8 @@
           </p:sp>
         </mc:Fallback>
       </mc:AlternateContent>
-      <mc:AlternateContent xmlns:mc="http://schemas.openxmlformats.org/markup-compatibility/2006">
-        <mc:Choice xmlns:a14="http://schemas.microsoft.com/office/drawing/2010/main" Requires="a14">
+      <mc:AlternateContent xmlns:mc="http://schemas.openxmlformats.org/markup-compatibility/2006" xmlns:a14="http://schemas.microsoft.com/office/drawing/2010/main">
+        <mc:Choice Requires="a14">
           <p:sp>
             <p:nvSpPr>
               <p:cNvPr id="14" name="Content Placeholder 2">
@@ -9933,7 +10286,7 @@
             </p:txBody>
           </p:sp>
         </mc:Choice>
-        <mc:Fallback>
+        <mc:Fallback xmlns="">
           <p:sp>
             <p:nvSpPr>
               <p:cNvPr id="14" name="Content Placeholder 2">
@@ -9978,8 +10331,8 @@
           </p:sp>
         </mc:Fallback>
       </mc:AlternateContent>
-      <mc:AlternateContent xmlns:mc="http://schemas.openxmlformats.org/markup-compatibility/2006">
-        <mc:Choice xmlns:a14="http://schemas.microsoft.com/office/drawing/2010/main" Requires="a14">
+      <mc:AlternateContent xmlns:mc="http://schemas.openxmlformats.org/markup-compatibility/2006" xmlns:a14="http://schemas.microsoft.com/office/drawing/2010/main">
+        <mc:Choice Requires="a14">
           <p:sp>
             <p:nvSpPr>
               <p:cNvPr id="15" name="Content Placeholder 2">
@@ -10198,7 +10551,7 @@
             </p:txBody>
           </p:sp>
         </mc:Choice>
-        <mc:Fallback>
+        <mc:Fallback xmlns="">
           <p:sp>
             <p:nvSpPr>
               <p:cNvPr id="15" name="Content Placeholder 2">
@@ -11564,8 +11917,8 @@
               </a:prstGeom>
             </p:spPr>
           </p:pic>
-          <mc:AlternateContent xmlns:mc="http://schemas.openxmlformats.org/markup-compatibility/2006">
-            <mc:Choice xmlns:a14="http://schemas.microsoft.com/office/drawing/2010/main" Requires="a14">
+          <mc:AlternateContent xmlns:mc="http://schemas.openxmlformats.org/markup-compatibility/2006" xmlns:a14="http://schemas.microsoft.com/office/drawing/2010/main">
+            <mc:Choice Requires="a14">
               <p:sp>
                 <p:nvSpPr>
                   <p:cNvPr id="35" name="Rectangle 34">
@@ -11593,6 +11946,7 @@
                   </a:bodyPr>
                   <a:lstStyle/>
                   <a:p>
+                    <a:pPr/>
                     <a14:m>
                       <m:oMathPara xmlns:m="http://schemas.openxmlformats.org/officeDocument/2006/math">
                         <m:oMathParaPr>
@@ -11644,7 +11998,7 @@
                 </p:txBody>
               </p:sp>
             </mc:Choice>
-            <mc:Fallback>
+            <mc:Fallback xmlns="">
               <p:sp>
                 <p:nvSpPr>
                   <p:cNvPr id="35" name="Rectangle 34">
@@ -11689,8 +12043,8 @@
               </p:sp>
             </mc:Fallback>
           </mc:AlternateContent>
-          <mc:AlternateContent xmlns:mc="http://schemas.openxmlformats.org/markup-compatibility/2006">
-            <mc:Choice xmlns:a14="http://schemas.microsoft.com/office/drawing/2010/main" Requires="a14">
+          <mc:AlternateContent xmlns:mc="http://schemas.openxmlformats.org/markup-compatibility/2006" xmlns:a14="http://schemas.microsoft.com/office/drawing/2010/main">
+            <mc:Choice Requires="a14">
               <p:sp>
                 <p:nvSpPr>
                   <p:cNvPr id="36" name="Rectangle 35">
@@ -11718,6 +12072,7 @@
                   </a:bodyPr>
                   <a:lstStyle/>
                   <a:p>
+                    <a:pPr/>
                     <a14:m>
                       <m:oMathPara xmlns:m="http://schemas.openxmlformats.org/officeDocument/2006/math">
                         <m:oMathParaPr>
@@ -11769,7 +12124,7 @@
                 </p:txBody>
               </p:sp>
             </mc:Choice>
-            <mc:Fallback>
+            <mc:Fallback xmlns="">
               <p:sp>
                 <p:nvSpPr>
                   <p:cNvPr id="36" name="Rectangle 35">
@@ -11814,8 +12169,8 @@
               </p:sp>
             </mc:Fallback>
           </mc:AlternateContent>
-          <mc:AlternateContent xmlns:mc="http://schemas.openxmlformats.org/markup-compatibility/2006">
-            <mc:Choice xmlns:a14="http://schemas.microsoft.com/office/drawing/2010/main" Requires="a14">
+          <mc:AlternateContent xmlns:mc="http://schemas.openxmlformats.org/markup-compatibility/2006" xmlns:a14="http://schemas.microsoft.com/office/drawing/2010/main">
+            <mc:Choice Requires="a14">
               <p:sp>
                 <p:nvSpPr>
                   <p:cNvPr id="37" name="Rectangle 36">
@@ -11843,6 +12198,7 @@
                   </a:bodyPr>
                   <a:lstStyle/>
                   <a:p>
+                    <a:pPr/>
                     <a14:m>
                       <m:oMathPara xmlns:m="http://schemas.openxmlformats.org/officeDocument/2006/math">
                         <m:oMathParaPr>
@@ -11894,7 +12250,7 @@
                 </p:txBody>
               </p:sp>
             </mc:Choice>
-            <mc:Fallback>
+            <mc:Fallback xmlns="">
               <p:sp>
                 <p:nvSpPr>
                   <p:cNvPr id="37" name="Rectangle 36">
@@ -11941,6 +12297,318 @@
           </mc:AlternateContent>
         </p:grpSp>
       </p:grpSp>
+      <p:pic>
+        <p:nvPicPr>
+          <p:cNvPr id="22" name="Picture 2" descr="Related image">
+            <a:extLst>
+              <a:ext uri="{FF2B5EF4-FFF2-40B4-BE49-F238E27FC236}">
+                <a16:creationId xmlns:a16="http://schemas.microsoft.com/office/drawing/2014/main" id="{4C273014-D0BC-42C6-8F36-99843A08FABE}"/>
+              </a:ext>
+            </a:extLst>
+          </p:cNvPr>
+          <p:cNvPicPr>
+            <a:picLocks noChangeAspect="1" noChangeArrowheads="1"/>
+          </p:cNvPicPr>
+          <p:nvPr/>
+        </p:nvPicPr>
+        <p:blipFill>
+          <a:blip r:embed="rId9">
+            <a:extLst>
+              <a:ext uri="{28A0092B-C50C-407E-A947-70E740481C1C}">
+                <a14:useLocalDpi xmlns:a14="http://schemas.microsoft.com/office/drawing/2010/main" val="0"/>
+              </a:ext>
+            </a:extLst>
+          </a:blip>
+          <a:srcRect/>
+          <a:stretch>
+            <a:fillRect/>
+          </a:stretch>
+        </p:blipFill>
+        <p:spPr bwMode="auto">
+          <a:xfrm>
+            <a:off x="7312882" y="1017071"/>
+            <a:ext cx="919220" cy="919220"/>
+          </a:xfrm>
+          <a:prstGeom prst="rect">
+            <a:avLst/>
+          </a:prstGeom>
+          <a:noFill/>
+          <a:extLst>
+            <a:ext uri="{909E8E84-426E-40DD-AFC4-6F175D3DCCD1}">
+              <a14:hiddenFill xmlns:a14="http://schemas.microsoft.com/office/drawing/2010/main">
+                <a:solidFill>
+                  <a:srgbClr val="FFFFFF"/>
+                </a:solidFill>
+              </a14:hiddenFill>
+            </a:ext>
+          </a:extLst>
+        </p:spPr>
+      </p:pic>
+      <mc:AlternateContent xmlns:mc="http://schemas.openxmlformats.org/markup-compatibility/2006" xmlns:a14="http://schemas.microsoft.com/office/drawing/2010/main">
+        <mc:Choice Requires="a14">
+          <p:sp>
+            <p:nvSpPr>
+              <p:cNvPr id="38" name="Content Placeholder 2">
+                <a:extLst>
+                  <a:ext uri="{FF2B5EF4-FFF2-40B4-BE49-F238E27FC236}">
+                    <a16:creationId xmlns:a16="http://schemas.microsoft.com/office/drawing/2014/main" id="{A460BCED-044D-4C93-9AF2-57171EC4EBFA}"/>
+                  </a:ext>
+                </a:extLst>
+              </p:cNvPr>
+              <p:cNvSpPr txBox="1">
+                <a:spLocks/>
+              </p:cNvSpPr>
+              <p:nvPr/>
+            </p:nvSpPr>
+            <p:spPr>
+              <a:xfrm>
+                <a:off x="7501450" y="1858128"/>
+                <a:ext cx="463151" cy="253763"/>
+              </a:xfrm>
+              <a:prstGeom prst="rect">
+                <a:avLst/>
+              </a:prstGeom>
+            </p:spPr>
+            <p:txBody>
+              <a:bodyPr/>
+              <a:lstStyle>
+                <a:lvl1pPr marL="342900" indent="-342900" algn="l" defTabSz="457200" rtl="0" eaLnBrk="1" latinLnBrk="0" hangingPunct="1">
+                  <a:spcBef>
+                    <a:spcPct val="20000"/>
+                  </a:spcBef>
+                  <a:buFont typeface="Arial"/>
+                  <a:buChar char="•"/>
+                  <a:defRPr sz="3200" kern="1200">
+                    <a:solidFill>
+                      <a:schemeClr val="tx1"/>
+                    </a:solidFill>
+                    <a:latin typeface="+mn-lt"/>
+                    <a:ea typeface="+mn-ea"/>
+                    <a:cs typeface="+mn-cs"/>
+                  </a:defRPr>
+                </a:lvl1pPr>
+                <a:lvl2pPr marL="742950" indent="-285750" algn="l" defTabSz="457200" rtl="0" eaLnBrk="1" latinLnBrk="0" hangingPunct="1">
+                  <a:spcBef>
+                    <a:spcPct val="20000"/>
+                  </a:spcBef>
+                  <a:buFont typeface="Arial"/>
+                  <a:buChar char="–"/>
+                  <a:defRPr sz="2800" kern="1200">
+                    <a:solidFill>
+                      <a:schemeClr val="tx1"/>
+                    </a:solidFill>
+                    <a:latin typeface="+mn-lt"/>
+                    <a:ea typeface="+mn-ea"/>
+                    <a:cs typeface="+mn-cs"/>
+                  </a:defRPr>
+                </a:lvl2pPr>
+                <a:lvl3pPr marL="1143000" indent="-228600" algn="l" defTabSz="457200" rtl="0" eaLnBrk="1" latinLnBrk="0" hangingPunct="1">
+                  <a:spcBef>
+                    <a:spcPct val="20000"/>
+                  </a:spcBef>
+                  <a:buFont typeface="Arial"/>
+                  <a:buChar char="•"/>
+                  <a:defRPr sz="2400" kern="1200">
+                    <a:solidFill>
+                      <a:schemeClr val="tx1"/>
+                    </a:solidFill>
+                    <a:latin typeface="+mn-lt"/>
+                    <a:ea typeface="+mn-ea"/>
+                    <a:cs typeface="+mn-cs"/>
+                  </a:defRPr>
+                </a:lvl3pPr>
+                <a:lvl4pPr marL="1600200" indent="-228600" algn="l" defTabSz="457200" rtl="0" eaLnBrk="1" latinLnBrk="0" hangingPunct="1">
+                  <a:spcBef>
+                    <a:spcPct val="20000"/>
+                  </a:spcBef>
+                  <a:buFont typeface="Arial"/>
+                  <a:buChar char="–"/>
+                  <a:defRPr sz="2000" kern="1200">
+                    <a:solidFill>
+                      <a:schemeClr val="tx1"/>
+                    </a:solidFill>
+                    <a:latin typeface="+mn-lt"/>
+                    <a:ea typeface="+mn-ea"/>
+                    <a:cs typeface="+mn-cs"/>
+                  </a:defRPr>
+                </a:lvl4pPr>
+                <a:lvl5pPr marL="2057400" indent="-228600" algn="l" defTabSz="457200" rtl="0" eaLnBrk="1" latinLnBrk="0" hangingPunct="1">
+                  <a:spcBef>
+                    <a:spcPct val="20000"/>
+                  </a:spcBef>
+                  <a:buFont typeface="Arial"/>
+                  <a:buChar char="»"/>
+                  <a:defRPr sz="2000" kern="1200">
+                    <a:solidFill>
+                      <a:schemeClr val="tx1"/>
+                    </a:solidFill>
+                    <a:latin typeface="+mn-lt"/>
+                    <a:ea typeface="+mn-ea"/>
+                    <a:cs typeface="+mn-cs"/>
+                  </a:defRPr>
+                </a:lvl5pPr>
+                <a:lvl6pPr marL="2514600" indent="-228600" algn="l" defTabSz="457200" rtl="0" eaLnBrk="1" latinLnBrk="0" hangingPunct="1">
+                  <a:spcBef>
+                    <a:spcPct val="20000"/>
+                  </a:spcBef>
+                  <a:buFont typeface="Arial"/>
+                  <a:buChar char="•"/>
+                  <a:defRPr sz="2000" kern="1200">
+                    <a:solidFill>
+                      <a:schemeClr val="tx1"/>
+                    </a:solidFill>
+                    <a:latin typeface="+mn-lt"/>
+                    <a:ea typeface="+mn-ea"/>
+                    <a:cs typeface="+mn-cs"/>
+                  </a:defRPr>
+                </a:lvl6pPr>
+                <a:lvl7pPr marL="2971800" indent="-228600" algn="l" defTabSz="457200" rtl="0" eaLnBrk="1" latinLnBrk="0" hangingPunct="1">
+                  <a:spcBef>
+                    <a:spcPct val="20000"/>
+                  </a:spcBef>
+                  <a:buFont typeface="Arial"/>
+                  <a:buChar char="•"/>
+                  <a:defRPr sz="2000" kern="1200">
+                    <a:solidFill>
+                      <a:schemeClr val="tx1"/>
+                    </a:solidFill>
+                    <a:latin typeface="+mn-lt"/>
+                    <a:ea typeface="+mn-ea"/>
+                    <a:cs typeface="+mn-cs"/>
+                  </a:defRPr>
+                </a:lvl7pPr>
+                <a:lvl8pPr marL="3429000" indent="-228600" algn="l" defTabSz="457200" rtl="0" eaLnBrk="1" latinLnBrk="0" hangingPunct="1">
+                  <a:spcBef>
+                    <a:spcPct val="20000"/>
+                  </a:spcBef>
+                  <a:buFont typeface="Arial"/>
+                  <a:buChar char="•"/>
+                  <a:defRPr sz="2000" kern="1200">
+                    <a:solidFill>
+                      <a:schemeClr val="tx1"/>
+                    </a:solidFill>
+                    <a:latin typeface="+mn-lt"/>
+                    <a:ea typeface="+mn-ea"/>
+                    <a:cs typeface="+mn-cs"/>
+                  </a:defRPr>
+                </a:lvl8pPr>
+                <a:lvl9pPr marL="3886200" indent="-228600" algn="l" defTabSz="457200" rtl="0" eaLnBrk="1" latinLnBrk="0" hangingPunct="1">
+                  <a:spcBef>
+                    <a:spcPct val="20000"/>
+                  </a:spcBef>
+                  <a:buFont typeface="Arial"/>
+                  <a:buChar char="•"/>
+                  <a:defRPr sz="2000" kern="1200">
+                    <a:solidFill>
+                      <a:schemeClr val="tx1"/>
+                    </a:solidFill>
+                    <a:latin typeface="+mn-lt"/>
+                    <a:ea typeface="+mn-ea"/>
+                    <a:cs typeface="+mn-cs"/>
+                  </a:defRPr>
+                </a:lvl9pPr>
+              </a:lstStyle>
+              <a:p>
+                <a:pPr marL="0" indent="0">
+                  <a:buFont typeface="Arial"/>
+                  <a:buNone/>
+                </a:pPr>
+                <a14:m>
+                  <m:oMathPara xmlns:m="http://schemas.openxmlformats.org/officeDocument/2006/math">
+                    <m:oMathParaPr>
+                      <m:jc m:val="centerGroup"/>
+                    </m:oMathParaPr>
+                    <m:oMath xmlns:m="http://schemas.openxmlformats.org/officeDocument/2006/math">
+                      <m:sSub>
+                        <m:sSubPr>
+                          <m:ctrlPr>
+                            <a:rPr lang="en-US" sz="1800" b="1" i="1" dirty="0" smtClean="0">
+                              <a:solidFill>
+                                <a:srgbClr val="13294B"/>
+                              </a:solidFill>
+                              <a:latin typeface="Cambria Math" panose="02040503050406030204" pitchFamily="18" charset="0"/>
+                              <a:cs typeface="Calibri" charset="0"/>
+                            </a:rPr>
+                          </m:ctrlPr>
+                        </m:sSubPr>
+                        <m:e>
+                          <m:r>
+                            <a:rPr lang="en-US" sz="1800" b="1" i="1" dirty="0" smtClean="0">
+                              <a:solidFill>
+                                <a:srgbClr val="13294B"/>
+                              </a:solidFill>
+                              <a:latin typeface="Cambria Math" panose="02040503050406030204" pitchFamily="18" charset="0"/>
+                              <a:cs typeface="Calibri" charset="0"/>
+                            </a:rPr>
+                            <m:t>𝑫</m:t>
+                          </m:r>
+                        </m:e>
+                        <m:sub>
+                          <m:r>
+                            <a:rPr lang="en-US" sz="1800" b="1" i="1" dirty="0" smtClean="0">
+                              <a:solidFill>
+                                <a:srgbClr val="13294B"/>
+                              </a:solidFill>
+                              <a:latin typeface="Cambria Math" panose="02040503050406030204" pitchFamily="18" charset="0"/>
+                              <a:cs typeface="Calibri" charset="0"/>
+                            </a:rPr>
+                            <m:t>𝑻</m:t>
+                          </m:r>
+                        </m:sub>
+                      </m:sSub>
+                    </m:oMath>
+                  </m:oMathPara>
+                </a14:m>
+                <a:endParaRPr lang="en-US" sz="1800" b="1" i="1" dirty="0"/>
+              </a:p>
+            </p:txBody>
+          </p:sp>
+        </mc:Choice>
+        <mc:Fallback xmlns="">
+          <p:sp>
+            <p:nvSpPr>
+              <p:cNvPr id="38" name="Content Placeholder 2">
+                <a:extLst>
+                  <a:ext uri="{FF2B5EF4-FFF2-40B4-BE49-F238E27FC236}">
+                    <a16:creationId xmlns:a16="http://schemas.microsoft.com/office/drawing/2014/main" id="{A460BCED-044D-4C93-9AF2-57171EC4EBFA}"/>
+                  </a:ext>
+                </a:extLst>
+              </p:cNvPr>
+              <p:cNvSpPr txBox="1">
+                <a:spLocks noRot="1" noChangeAspect="1" noMove="1" noResize="1" noEditPoints="1" noAdjustHandles="1" noChangeArrowheads="1" noChangeShapeType="1" noTextEdit="1"/>
+              </p:cNvSpPr>
+              <p:nvPr/>
+            </p:nvSpPr>
+            <p:spPr>
+              <a:xfrm>
+                <a:off x="7501450" y="1858128"/>
+                <a:ext cx="463151" cy="253763"/>
+              </a:xfrm>
+              <a:prstGeom prst="rect">
+                <a:avLst/>
+              </a:prstGeom>
+              <a:blipFill>
+                <a:blip r:embed="rId10"/>
+                <a:stretch>
+                  <a:fillRect b="-48780"/>
+                </a:stretch>
+              </a:blipFill>
+            </p:spPr>
+            <p:txBody>
+              <a:bodyPr/>
+              <a:lstStyle/>
+              <a:p>
+                <a:r>
+                  <a:rPr lang="en-US">
+                    <a:noFill/>
+                  </a:rPr>
+                  <a:t> </a:t>
+                </a:r>
+              </a:p>
+            </p:txBody>
+          </p:sp>
+        </mc:Fallback>
+      </mc:AlternateContent>
     </p:spTree>
     <p:extLst>
       <p:ext uri="{BB962C8B-B14F-4D97-AF65-F5344CB8AC3E}">
@@ -12133,8 +12801,8 @@
           </a:p>
         </p:txBody>
       </p:sp>
-      <mc:AlternateContent xmlns:mc="http://schemas.openxmlformats.org/markup-compatibility/2006">
-        <mc:Choice xmlns:a14="http://schemas.microsoft.com/office/drawing/2010/main" Requires="a14">
+      <mc:AlternateContent xmlns:mc="http://schemas.openxmlformats.org/markup-compatibility/2006" xmlns:a14="http://schemas.microsoft.com/office/drawing/2010/main">
+        <mc:Choice Requires="a14">
           <p:sp>
             <p:nvSpPr>
               <p:cNvPr id="2" name="Rectangle 1">
@@ -12236,7 +12904,7 @@
             </p:txBody>
           </p:sp>
         </mc:Choice>
-        <mc:Fallback>
+        <mc:Fallback xmlns="">
           <p:sp>
             <p:nvSpPr>
               <p:cNvPr id="2" name="Rectangle 1">
@@ -12281,8 +12949,8 @@
           </p:sp>
         </mc:Fallback>
       </mc:AlternateContent>
-      <mc:AlternateContent xmlns:mc="http://schemas.openxmlformats.org/markup-compatibility/2006">
-        <mc:Choice xmlns:a14="http://schemas.microsoft.com/office/drawing/2010/main" Requires="a14">
+      <mc:AlternateContent xmlns:mc="http://schemas.openxmlformats.org/markup-compatibility/2006" xmlns:a14="http://schemas.microsoft.com/office/drawing/2010/main">
+        <mc:Choice Requires="a14">
           <p:sp>
             <p:nvSpPr>
               <p:cNvPr id="6" name="Rectangle 5">
@@ -12413,13 +13081,13 @@
                     <a:latin typeface="Calibri" charset="0"/>
                     <a:cs typeface="Calibri" charset="0"/>
                   </a:rPr>
-                  <a:t> can take,</a:t>
+                  <a:t> can take, our objective is:</a:t>
                 </a:r>
               </a:p>
             </p:txBody>
           </p:sp>
         </mc:Choice>
-        <mc:Fallback>
+        <mc:Fallback xmlns="">
           <p:sp>
             <p:nvSpPr>
               <p:cNvPr id="6" name="Rectangle 5">
@@ -12494,8 +13162,8 @@
           </a:prstGeom>
         </p:spPr>
       </p:pic>
-      <mc:AlternateContent xmlns:mc="http://schemas.openxmlformats.org/markup-compatibility/2006">
-        <mc:Choice xmlns:a14="http://schemas.microsoft.com/office/drawing/2010/main" Requires="a14">
+      <mc:AlternateContent xmlns:mc="http://schemas.openxmlformats.org/markup-compatibility/2006" xmlns:a14="http://schemas.microsoft.com/office/drawing/2010/main">
+        <mc:Choice Requires="a14">
           <p:sp>
             <p:nvSpPr>
               <p:cNvPr id="5" name="Rectangle 4">
@@ -12664,17 +13332,7 @@
                         <a:latin typeface="Cambria Math" panose="02040503050406030204" pitchFamily="18" charset="0"/>
                         <a:cs typeface="Calibri" charset="0"/>
                       </a:rPr>
-                      <m:t>)</m:t>
-                    </m:r>
-                    <m:r>
-                      <a:rPr lang="en-US" b="1" i="1" dirty="0">
-                        <a:solidFill>
-                          <a:srgbClr val="13294B"/>
-                        </a:solidFill>
-                        <a:latin typeface="Cambria Math" panose="02040503050406030204" pitchFamily="18" charset="0"/>
-                        <a:cs typeface="Calibri" charset="0"/>
-                      </a:rPr>
-                      <m:t> </m:t>
+                      <m:t>) </m:t>
                     </m:r>
                   </m:oMath>
                 </a14:m>
@@ -12689,7 +13347,7 @@
             </p:txBody>
           </p:sp>
         </mc:Choice>
-        <mc:Fallback>
+        <mc:Fallback xmlns="">
           <p:sp>
             <p:nvSpPr>
               <p:cNvPr id="5" name="Rectangle 4">
@@ -12794,8 +13452,8 @@
           </a:prstGeom>
         </p:spPr>
       </p:pic>
-      <mc:AlternateContent xmlns:mc="http://schemas.openxmlformats.org/markup-compatibility/2006">
-        <mc:Choice xmlns:a14="http://schemas.microsoft.com/office/drawing/2010/main" Requires="a14">
+      <mc:AlternateContent xmlns:mc="http://schemas.openxmlformats.org/markup-compatibility/2006" xmlns:a14="http://schemas.microsoft.com/office/drawing/2010/main">
+        <mc:Choice Requires="a14">
           <p:sp>
             <p:nvSpPr>
               <p:cNvPr id="11" name="Rectangle 10">
@@ -13038,7 +13696,7 @@
                         <a:solidFill>
                           <a:srgbClr val="13294B"/>
                         </a:solidFill>
-                        <a:latin typeface="Calibri" charset="0"/>
+                        <a:latin typeface="Cambria Math" panose="02040503050406030204" pitchFamily="18" charset="0"/>
                         <a:cs typeface="Calibri" charset="0"/>
                       </a:rPr>
                       <m:t>𝑖</m:t>
@@ -13143,11 +13801,11 @@
                     <m:sSub>
                       <m:sSubPr>
                         <m:ctrlPr>
-                          <a:rPr lang="en-US" dirty="0">
+                          <a:rPr lang="en-US" i="1" dirty="0">
                             <a:solidFill>
                               <a:srgbClr val="13294B"/>
                             </a:solidFill>
-                            <a:latin typeface="Calibri" charset="0"/>
+                            <a:latin typeface="Cambria Math" panose="02040503050406030204" pitchFamily="18" charset="0"/>
                             <a:cs typeface="Calibri" charset="0"/>
                           </a:rPr>
                         </m:ctrlPr>
@@ -13158,7 +13816,7 @@
                             <a:solidFill>
                               <a:srgbClr val="13294B"/>
                             </a:solidFill>
-                            <a:latin typeface="Calibri" charset="0"/>
+                            <a:latin typeface="Cambria Math" panose="02040503050406030204" pitchFamily="18" charset="0"/>
                             <a:cs typeface="Calibri" charset="0"/>
                           </a:rPr>
                           <m:t>𝑥</m:t>
@@ -13170,7 +13828,7 @@
                             <a:solidFill>
                               <a:srgbClr val="13294B"/>
                             </a:solidFill>
-                            <a:latin typeface="Calibri" charset="0"/>
+                            <a:latin typeface="Cambria Math" panose="02040503050406030204" pitchFamily="18" charset="0"/>
                             <a:cs typeface="Calibri" charset="0"/>
                           </a:rPr>
                           <m:t>𝑖</m:t>
@@ -13196,7 +13854,7 @@
                         <a:solidFill>
                           <a:srgbClr val="13294B"/>
                         </a:solidFill>
-                        <a:latin typeface="Calibri" charset="0"/>
+                        <a:latin typeface="Cambria Math" panose="02040503050406030204" pitchFamily="18" charset="0"/>
                         <a:cs typeface="Calibri" charset="0"/>
                       </a:rPr>
                       <m:t>𝑙</m:t>
@@ -13218,11 +13876,11 @@
                     <m:sSub>
                       <m:sSubPr>
                         <m:ctrlPr>
-                          <a:rPr lang="en-US" dirty="0">
+                          <a:rPr lang="en-US" i="1" dirty="0">
                             <a:solidFill>
                               <a:srgbClr val="13294B"/>
                             </a:solidFill>
-                            <a:latin typeface="Calibri" charset="0"/>
+                            <a:latin typeface="Cambria Math" panose="02040503050406030204" pitchFamily="18" charset="0"/>
                             <a:cs typeface="Calibri" charset="0"/>
                           </a:rPr>
                         </m:ctrlPr>
@@ -13233,7 +13891,7 @@
                             <a:solidFill>
                               <a:srgbClr val="13294B"/>
                             </a:solidFill>
-                            <a:latin typeface="Calibri" charset="0"/>
+                            <a:latin typeface="Cambria Math" panose="02040503050406030204" pitchFamily="18" charset="0"/>
                             <a:cs typeface="Calibri" charset="0"/>
                           </a:rPr>
                           <m:t>𝑷</m:t>
@@ -13244,11 +13902,11 @@
                           <m:accPr>
                             <m:chr m:val="̃"/>
                             <m:ctrlPr>
-                              <a:rPr lang="en-US">
+                              <a:rPr lang="en-US" i="1">
                                 <a:solidFill>
                                   <a:srgbClr val="13294B"/>
                                 </a:solidFill>
-                                <a:latin typeface="Calibri" charset="0"/>
+                                <a:latin typeface="Cambria Math" panose="02040503050406030204" pitchFamily="18" charset="0"/>
                                 <a:cs typeface="Calibri" charset="0"/>
                               </a:rPr>
                             </m:ctrlPr>
@@ -13259,7 +13917,7 @@
                                 <a:solidFill>
                                   <a:srgbClr val="13294B"/>
                                 </a:solidFill>
-                                <a:latin typeface="Calibri" charset="0"/>
+                                <a:latin typeface="Cambria Math" panose="02040503050406030204" pitchFamily="18" charset="0"/>
                                 <a:cs typeface="Calibri" charset="0"/>
                               </a:rPr>
                               <m:t>𝐺</m:t>
@@ -13273,7 +13931,7 @@
                         <a:solidFill>
                           <a:srgbClr val="13294B"/>
                         </a:solidFill>
-                        <a:latin typeface="Calibri" charset="0"/>
+                        <a:latin typeface="Cambria Math" panose="02040503050406030204" pitchFamily="18" charset="0"/>
                         <a:cs typeface="Calibri" charset="0"/>
                       </a:rPr>
                       <m:t>(</m:t>
@@ -13283,7 +13941,7 @@
                         <a:solidFill>
                           <a:srgbClr val="13294B"/>
                         </a:solidFill>
-                        <a:latin typeface="Calibri" charset="0"/>
+                        <a:latin typeface="Cambria Math" panose="02040503050406030204" pitchFamily="18" charset="0"/>
                         <a:cs typeface="Calibri" charset="0"/>
                       </a:rPr>
                       <m:t>𝑖</m:t>
@@ -13293,7 +13951,7 @@
                         <a:solidFill>
                           <a:srgbClr val="13294B"/>
                         </a:solidFill>
-                        <a:latin typeface="Calibri" charset="0"/>
+                        <a:latin typeface="Cambria Math" panose="02040503050406030204" pitchFamily="18" charset="0"/>
                         <a:cs typeface="Calibri" charset="0"/>
                       </a:rPr>
                       <m:t>)</m:t>
@@ -13317,7 +13975,7 @@
                         <a:solidFill>
                           <a:srgbClr val="13294B"/>
                         </a:solidFill>
-                        <a:latin typeface="Calibri" charset="0"/>
+                        <a:latin typeface="Cambria Math" panose="02040503050406030204" pitchFamily="18" charset="0"/>
                         <a:cs typeface="Calibri" charset="0"/>
                       </a:rPr>
                       <m:t>𝑐</m:t>
@@ -13338,7 +13996,7 @@
             </p:txBody>
           </p:sp>
         </mc:Choice>
-        <mc:Fallback>
+        <mc:Fallback xmlns="">
           <p:sp>
             <p:nvSpPr>
               <p:cNvPr id="11" name="Rectangle 10">
@@ -13383,36 +14041,399 @@
           </p:sp>
         </mc:Fallback>
       </mc:AlternateContent>
+      <p:grpSp>
+        <p:nvGrpSpPr>
+          <p:cNvPr id="14" name="Group 13">
+            <a:extLst>
+              <a:ext uri="{FF2B5EF4-FFF2-40B4-BE49-F238E27FC236}">
+                <a16:creationId xmlns:a16="http://schemas.microsoft.com/office/drawing/2014/main" id="{1046D39E-0592-423F-8550-1E973C2D492D}"/>
+              </a:ext>
+            </a:extLst>
+          </p:cNvPr>
+          <p:cNvGrpSpPr/>
+          <p:nvPr/>
+        </p:nvGrpSpPr>
+        <p:grpSpPr>
+          <a:xfrm>
+            <a:off x="2577483" y="6372182"/>
+            <a:ext cx="2430106" cy="412756"/>
+            <a:chOff x="2608684" y="6384929"/>
+            <a:chExt cx="2430106" cy="412756"/>
+          </a:xfrm>
+        </p:grpSpPr>
+        <p:pic>
+          <p:nvPicPr>
+            <p:cNvPr id="12" name="Picture 11">
+              <a:extLst>
+                <a:ext uri="{FF2B5EF4-FFF2-40B4-BE49-F238E27FC236}">
+                  <a16:creationId xmlns:a16="http://schemas.microsoft.com/office/drawing/2014/main" id="{A2A15B55-D5C6-4248-AACB-CD2FADAEA248}"/>
+                </a:ext>
+              </a:extLst>
+            </p:cNvPr>
+            <p:cNvPicPr>
+              <a:picLocks noChangeAspect="1"/>
+            </p:cNvPicPr>
+            <p:nvPr/>
+          </p:nvPicPr>
+          <p:blipFill>
+            <a:blip r:embed="rId10"/>
+            <a:stretch>
+              <a:fillRect/>
+            </a:stretch>
+          </p:blipFill>
+          <p:spPr>
+            <a:xfrm>
+              <a:off x="2694198" y="6475149"/>
+              <a:ext cx="2344592" cy="322536"/>
+            </a:xfrm>
+            <a:prstGeom prst="rect">
+              <a:avLst/>
+            </a:prstGeom>
+          </p:spPr>
+        </p:pic>
+        <p:pic>
+          <p:nvPicPr>
+            <p:cNvPr id="13" name="Picture 12">
+              <a:extLst>
+                <a:ext uri="{FF2B5EF4-FFF2-40B4-BE49-F238E27FC236}">
+                  <a16:creationId xmlns:a16="http://schemas.microsoft.com/office/drawing/2014/main" id="{E0892D9A-28E0-40FB-B888-9054994CFBB2}"/>
+                </a:ext>
+              </a:extLst>
+            </p:cNvPr>
+            <p:cNvPicPr>
+              <a:picLocks noChangeAspect="1"/>
+            </p:cNvPicPr>
+            <p:nvPr/>
+          </p:nvPicPr>
+          <p:blipFill>
+            <a:blip r:embed="rId11"/>
+            <a:stretch>
+              <a:fillRect/>
+            </a:stretch>
+          </p:blipFill>
+          <p:spPr>
+            <a:xfrm>
+              <a:off x="2608684" y="6384929"/>
+              <a:ext cx="295316" cy="314369"/>
+            </a:xfrm>
+            <a:prstGeom prst="rect">
+              <a:avLst/>
+            </a:prstGeom>
+          </p:spPr>
+        </p:pic>
+      </p:grpSp>
       <p:pic>
         <p:nvPicPr>
-          <p:cNvPr id="12" name="Picture 11">
+          <p:cNvPr id="17" name="Picture 2" descr="Related image">
             <a:extLst>
               <a:ext uri="{FF2B5EF4-FFF2-40B4-BE49-F238E27FC236}">
-                <a16:creationId xmlns:a16="http://schemas.microsoft.com/office/drawing/2014/main" id="{A2A15B55-D5C6-4248-AACB-CD2FADAEA248}"/>
+                <a16:creationId xmlns:a16="http://schemas.microsoft.com/office/drawing/2014/main" id="{1833C4B9-CD49-451C-8892-6DDECBA51AEA}"/>
               </a:ext>
             </a:extLst>
           </p:cNvPr>
           <p:cNvPicPr>
-            <a:picLocks noChangeAspect="1"/>
+            <a:picLocks noChangeAspect="1" noChangeArrowheads="1"/>
           </p:cNvPicPr>
           <p:nvPr/>
         </p:nvPicPr>
         <p:blipFill>
-          <a:blip r:embed="rId10"/>
+          <a:blip r:embed="rId12">
+            <a:extLst>
+              <a:ext uri="{28A0092B-C50C-407E-A947-70E740481C1C}">
+                <a14:useLocalDpi xmlns:a14="http://schemas.microsoft.com/office/drawing/2010/main" val="0"/>
+              </a:ext>
+            </a:extLst>
+          </a:blip>
+          <a:srcRect/>
           <a:stretch>
             <a:fillRect/>
           </a:stretch>
         </p:blipFill>
-        <p:spPr>
+        <p:spPr bwMode="auto">
           <a:xfrm>
-            <a:off x="2694198" y="6475149"/>
-            <a:ext cx="2344592" cy="322536"/>
+            <a:off x="7312882" y="1017071"/>
+            <a:ext cx="919220" cy="919220"/>
           </a:xfrm>
           <a:prstGeom prst="rect">
             <a:avLst/>
           </a:prstGeom>
+          <a:noFill/>
+          <a:extLst>
+            <a:ext uri="{909E8E84-426E-40DD-AFC4-6F175D3DCCD1}">
+              <a14:hiddenFill xmlns:a14="http://schemas.microsoft.com/office/drawing/2010/main">
+                <a:solidFill>
+                  <a:srgbClr val="FFFFFF"/>
+                </a:solidFill>
+              </a14:hiddenFill>
+            </a:ext>
+          </a:extLst>
         </p:spPr>
       </p:pic>
+      <mc:AlternateContent xmlns:mc="http://schemas.openxmlformats.org/markup-compatibility/2006" xmlns:a14="http://schemas.microsoft.com/office/drawing/2010/main">
+        <mc:Choice Requires="a14">
+          <p:sp>
+            <p:nvSpPr>
+              <p:cNvPr id="18" name="Content Placeholder 2">
+                <a:extLst>
+                  <a:ext uri="{FF2B5EF4-FFF2-40B4-BE49-F238E27FC236}">
+                    <a16:creationId xmlns:a16="http://schemas.microsoft.com/office/drawing/2014/main" id="{B2458D15-C861-42D6-80B8-8EF16992C5FC}"/>
+                  </a:ext>
+                </a:extLst>
+              </p:cNvPr>
+              <p:cNvSpPr txBox="1">
+                <a:spLocks/>
+              </p:cNvSpPr>
+              <p:nvPr/>
+            </p:nvSpPr>
+            <p:spPr>
+              <a:xfrm>
+                <a:off x="7501450" y="1858128"/>
+                <a:ext cx="463151" cy="253763"/>
+              </a:xfrm>
+              <a:prstGeom prst="rect">
+                <a:avLst/>
+              </a:prstGeom>
+            </p:spPr>
+            <p:txBody>
+              <a:bodyPr/>
+              <a:lstStyle>
+                <a:lvl1pPr marL="342900" indent="-342900" algn="l" defTabSz="457200" rtl="0" eaLnBrk="1" latinLnBrk="0" hangingPunct="1">
+                  <a:spcBef>
+                    <a:spcPct val="20000"/>
+                  </a:spcBef>
+                  <a:buFont typeface="Arial"/>
+                  <a:buChar char="•"/>
+                  <a:defRPr sz="3200" kern="1200">
+                    <a:solidFill>
+                      <a:schemeClr val="tx1"/>
+                    </a:solidFill>
+                    <a:latin typeface="+mn-lt"/>
+                    <a:ea typeface="+mn-ea"/>
+                    <a:cs typeface="+mn-cs"/>
+                  </a:defRPr>
+                </a:lvl1pPr>
+                <a:lvl2pPr marL="742950" indent="-285750" algn="l" defTabSz="457200" rtl="0" eaLnBrk="1" latinLnBrk="0" hangingPunct="1">
+                  <a:spcBef>
+                    <a:spcPct val="20000"/>
+                  </a:spcBef>
+                  <a:buFont typeface="Arial"/>
+                  <a:buChar char="–"/>
+                  <a:defRPr sz="2800" kern="1200">
+                    <a:solidFill>
+                      <a:schemeClr val="tx1"/>
+                    </a:solidFill>
+                    <a:latin typeface="+mn-lt"/>
+                    <a:ea typeface="+mn-ea"/>
+                    <a:cs typeface="+mn-cs"/>
+                  </a:defRPr>
+                </a:lvl2pPr>
+                <a:lvl3pPr marL="1143000" indent="-228600" algn="l" defTabSz="457200" rtl="0" eaLnBrk="1" latinLnBrk="0" hangingPunct="1">
+                  <a:spcBef>
+                    <a:spcPct val="20000"/>
+                  </a:spcBef>
+                  <a:buFont typeface="Arial"/>
+                  <a:buChar char="•"/>
+                  <a:defRPr sz="2400" kern="1200">
+                    <a:solidFill>
+                      <a:schemeClr val="tx1"/>
+                    </a:solidFill>
+                    <a:latin typeface="+mn-lt"/>
+                    <a:ea typeface="+mn-ea"/>
+                    <a:cs typeface="+mn-cs"/>
+                  </a:defRPr>
+                </a:lvl3pPr>
+                <a:lvl4pPr marL="1600200" indent="-228600" algn="l" defTabSz="457200" rtl="0" eaLnBrk="1" latinLnBrk="0" hangingPunct="1">
+                  <a:spcBef>
+                    <a:spcPct val="20000"/>
+                  </a:spcBef>
+                  <a:buFont typeface="Arial"/>
+                  <a:buChar char="–"/>
+                  <a:defRPr sz="2000" kern="1200">
+                    <a:solidFill>
+                      <a:schemeClr val="tx1"/>
+                    </a:solidFill>
+                    <a:latin typeface="+mn-lt"/>
+                    <a:ea typeface="+mn-ea"/>
+                    <a:cs typeface="+mn-cs"/>
+                  </a:defRPr>
+                </a:lvl4pPr>
+                <a:lvl5pPr marL="2057400" indent="-228600" algn="l" defTabSz="457200" rtl="0" eaLnBrk="1" latinLnBrk="0" hangingPunct="1">
+                  <a:spcBef>
+                    <a:spcPct val="20000"/>
+                  </a:spcBef>
+                  <a:buFont typeface="Arial"/>
+                  <a:buChar char="»"/>
+                  <a:defRPr sz="2000" kern="1200">
+                    <a:solidFill>
+                      <a:schemeClr val="tx1"/>
+                    </a:solidFill>
+                    <a:latin typeface="+mn-lt"/>
+                    <a:ea typeface="+mn-ea"/>
+                    <a:cs typeface="+mn-cs"/>
+                  </a:defRPr>
+                </a:lvl5pPr>
+                <a:lvl6pPr marL="2514600" indent="-228600" algn="l" defTabSz="457200" rtl="0" eaLnBrk="1" latinLnBrk="0" hangingPunct="1">
+                  <a:spcBef>
+                    <a:spcPct val="20000"/>
+                  </a:spcBef>
+                  <a:buFont typeface="Arial"/>
+                  <a:buChar char="•"/>
+                  <a:defRPr sz="2000" kern="1200">
+                    <a:solidFill>
+                      <a:schemeClr val="tx1"/>
+                    </a:solidFill>
+                    <a:latin typeface="+mn-lt"/>
+                    <a:ea typeface="+mn-ea"/>
+                    <a:cs typeface="+mn-cs"/>
+                  </a:defRPr>
+                </a:lvl6pPr>
+                <a:lvl7pPr marL="2971800" indent="-228600" algn="l" defTabSz="457200" rtl="0" eaLnBrk="1" latinLnBrk="0" hangingPunct="1">
+                  <a:spcBef>
+                    <a:spcPct val="20000"/>
+                  </a:spcBef>
+                  <a:buFont typeface="Arial"/>
+                  <a:buChar char="•"/>
+                  <a:defRPr sz="2000" kern="1200">
+                    <a:solidFill>
+                      <a:schemeClr val="tx1"/>
+                    </a:solidFill>
+                    <a:latin typeface="+mn-lt"/>
+                    <a:ea typeface="+mn-ea"/>
+                    <a:cs typeface="+mn-cs"/>
+                  </a:defRPr>
+                </a:lvl7pPr>
+                <a:lvl8pPr marL="3429000" indent="-228600" algn="l" defTabSz="457200" rtl="0" eaLnBrk="1" latinLnBrk="0" hangingPunct="1">
+                  <a:spcBef>
+                    <a:spcPct val="20000"/>
+                  </a:spcBef>
+                  <a:buFont typeface="Arial"/>
+                  <a:buChar char="•"/>
+                  <a:defRPr sz="2000" kern="1200">
+                    <a:solidFill>
+                      <a:schemeClr val="tx1"/>
+                    </a:solidFill>
+                    <a:latin typeface="+mn-lt"/>
+                    <a:ea typeface="+mn-ea"/>
+                    <a:cs typeface="+mn-cs"/>
+                  </a:defRPr>
+                </a:lvl8pPr>
+                <a:lvl9pPr marL="3886200" indent="-228600" algn="l" defTabSz="457200" rtl="0" eaLnBrk="1" latinLnBrk="0" hangingPunct="1">
+                  <a:spcBef>
+                    <a:spcPct val="20000"/>
+                  </a:spcBef>
+                  <a:buFont typeface="Arial"/>
+                  <a:buChar char="•"/>
+                  <a:defRPr sz="2000" kern="1200">
+                    <a:solidFill>
+                      <a:schemeClr val="tx1"/>
+                    </a:solidFill>
+                    <a:latin typeface="+mn-lt"/>
+                    <a:ea typeface="+mn-ea"/>
+                    <a:cs typeface="+mn-cs"/>
+                  </a:defRPr>
+                </a:lvl9pPr>
+              </a:lstStyle>
+              <a:p>
+                <a:pPr marL="0" indent="0">
+                  <a:buFont typeface="Arial"/>
+                  <a:buNone/>
+                </a:pPr>
+                <a14:m>
+                  <m:oMathPara xmlns:m="http://schemas.openxmlformats.org/officeDocument/2006/math">
+                    <m:oMathParaPr>
+                      <m:jc m:val="centerGroup"/>
+                    </m:oMathParaPr>
+                    <m:oMath xmlns:m="http://schemas.openxmlformats.org/officeDocument/2006/math">
+                      <m:sSub>
+                        <m:sSubPr>
+                          <m:ctrlPr>
+                            <a:rPr lang="en-US" sz="1800" b="1" i="1" dirty="0" smtClean="0">
+                              <a:solidFill>
+                                <a:srgbClr val="13294B"/>
+                              </a:solidFill>
+                              <a:latin typeface="Cambria Math" panose="02040503050406030204" pitchFamily="18" charset="0"/>
+                              <a:cs typeface="Calibri" charset="0"/>
+                            </a:rPr>
+                          </m:ctrlPr>
+                        </m:sSubPr>
+                        <m:e>
+                          <m:r>
+                            <a:rPr lang="en-US" sz="1800" b="1" i="1" dirty="0" smtClean="0">
+                              <a:solidFill>
+                                <a:srgbClr val="13294B"/>
+                              </a:solidFill>
+                              <a:latin typeface="Cambria Math" panose="02040503050406030204" pitchFamily="18" charset="0"/>
+                              <a:cs typeface="Calibri" charset="0"/>
+                            </a:rPr>
+                            <m:t>𝑫</m:t>
+                          </m:r>
+                        </m:e>
+                        <m:sub>
+                          <m:r>
+                            <a:rPr lang="en-US" sz="1800" b="1" i="1" dirty="0" smtClean="0">
+                              <a:solidFill>
+                                <a:srgbClr val="13294B"/>
+                              </a:solidFill>
+                              <a:latin typeface="Cambria Math" panose="02040503050406030204" pitchFamily="18" charset="0"/>
+                              <a:cs typeface="Calibri" charset="0"/>
+                            </a:rPr>
+                            <m:t>𝑷</m:t>
+                          </m:r>
+                        </m:sub>
+                      </m:sSub>
+                    </m:oMath>
+                  </m:oMathPara>
+                </a14:m>
+                <a:endParaRPr lang="en-US" sz="1800" b="1" i="1" dirty="0"/>
+              </a:p>
+            </p:txBody>
+          </p:sp>
+        </mc:Choice>
+        <mc:Fallback xmlns="">
+          <p:sp>
+            <p:nvSpPr>
+              <p:cNvPr id="18" name="Content Placeholder 2">
+                <a:extLst>
+                  <a:ext uri="{FF2B5EF4-FFF2-40B4-BE49-F238E27FC236}">
+                    <a16:creationId xmlns:a16="http://schemas.microsoft.com/office/drawing/2014/main" id="{B2458D15-C861-42D6-80B8-8EF16992C5FC}"/>
+                  </a:ext>
+                </a:extLst>
+              </p:cNvPr>
+              <p:cNvSpPr txBox="1">
+                <a:spLocks noRot="1" noChangeAspect="1" noMove="1" noResize="1" noEditPoints="1" noAdjustHandles="1" noChangeArrowheads="1" noChangeShapeType="1" noTextEdit="1"/>
+              </p:cNvSpPr>
+              <p:nvPr/>
+            </p:nvSpPr>
+            <p:spPr>
+              <a:xfrm>
+                <a:off x="7501450" y="1858128"/>
+                <a:ext cx="463151" cy="253763"/>
+              </a:xfrm>
+              <a:prstGeom prst="rect">
+                <a:avLst/>
+              </a:prstGeom>
+              <a:blipFill>
+                <a:blip r:embed="rId13"/>
+                <a:stretch>
+                  <a:fillRect b="-48780"/>
+                </a:stretch>
+              </a:blipFill>
+            </p:spPr>
+            <p:txBody>
+              <a:bodyPr/>
+              <a:lstStyle/>
+              <a:p>
+                <a:r>
+                  <a:rPr lang="en-US">
+                    <a:noFill/>
+                  </a:rPr>
+                  <a:t> </a:t>
+                </a:r>
+              </a:p>
+            </p:txBody>
+          </p:sp>
+        </mc:Fallback>
+      </mc:AlternateContent>
     </p:spTree>
     <p:extLst>
       <p:ext uri="{BB962C8B-B14F-4D97-AF65-F5344CB8AC3E}">
@@ -13765,6 +14786,318 @@
           </a:prstGeom>
         </p:spPr>
       </p:pic>
+      <p:pic>
+        <p:nvPicPr>
+          <p:cNvPr id="11" name="Picture 2" descr="Related image">
+            <a:extLst>
+              <a:ext uri="{FF2B5EF4-FFF2-40B4-BE49-F238E27FC236}">
+                <a16:creationId xmlns:a16="http://schemas.microsoft.com/office/drawing/2014/main" id="{496958DA-ED62-46CD-A596-8ACF0167B0AE}"/>
+              </a:ext>
+            </a:extLst>
+          </p:cNvPr>
+          <p:cNvPicPr>
+            <a:picLocks noChangeAspect="1" noChangeArrowheads="1"/>
+          </p:cNvPicPr>
+          <p:nvPr/>
+        </p:nvPicPr>
+        <p:blipFill>
+          <a:blip r:embed="rId7">
+            <a:extLst>
+              <a:ext uri="{28A0092B-C50C-407E-A947-70E740481C1C}">
+                <a14:useLocalDpi xmlns:a14="http://schemas.microsoft.com/office/drawing/2010/main" val="0"/>
+              </a:ext>
+            </a:extLst>
+          </a:blip>
+          <a:srcRect/>
+          <a:stretch>
+            <a:fillRect/>
+          </a:stretch>
+        </p:blipFill>
+        <p:spPr bwMode="auto">
+          <a:xfrm>
+            <a:off x="7312882" y="1017071"/>
+            <a:ext cx="919220" cy="919220"/>
+          </a:xfrm>
+          <a:prstGeom prst="rect">
+            <a:avLst/>
+          </a:prstGeom>
+          <a:noFill/>
+          <a:extLst>
+            <a:ext uri="{909E8E84-426E-40DD-AFC4-6F175D3DCCD1}">
+              <a14:hiddenFill xmlns:a14="http://schemas.microsoft.com/office/drawing/2010/main">
+                <a:solidFill>
+                  <a:srgbClr val="FFFFFF"/>
+                </a:solidFill>
+              </a14:hiddenFill>
+            </a:ext>
+          </a:extLst>
+        </p:spPr>
+      </p:pic>
+      <mc:AlternateContent xmlns:mc="http://schemas.openxmlformats.org/markup-compatibility/2006" xmlns:a14="http://schemas.microsoft.com/office/drawing/2010/main">
+        <mc:Choice Requires="a14">
+          <p:sp>
+            <p:nvSpPr>
+              <p:cNvPr id="12" name="Content Placeholder 2">
+                <a:extLst>
+                  <a:ext uri="{FF2B5EF4-FFF2-40B4-BE49-F238E27FC236}">
+                    <a16:creationId xmlns:a16="http://schemas.microsoft.com/office/drawing/2014/main" id="{5BD448EF-EE69-4527-899B-A822A4FD9FA7}"/>
+                  </a:ext>
+                </a:extLst>
+              </p:cNvPr>
+              <p:cNvSpPr txBox="1">
+                <a:spLocks/>
+              </p:cNvSpPr>
+              <p:nvPr/>
+            </p:nvSpPr>
+            <p:spPr>
+              <a:xfrm>
+                <a:off x="7501450" y="1858128"/>
+                <a:ext cx="463151" cy="253763"/>
+              </a:xfrm>
+              <a:prstGeom prst="rect">
+                <a:avLst/>
+              </a:prstGeom>
+            </p:spPr>
+            <p:txBody>
+              <a:bodyPr/>
+              <a:lstStyle>
+                <a:lvl1pPr marL="342900" indent="-342900" algn="l" defTabSz="457200" rtl="0" eaLnBrk="1" latinLnBrk="0" hangingPunct="1">
+                  <a:spcBef>
+                    <a:spcPct val="20000"/>
+                  </a:spcBef>
+                  <a:buFont typeface="Arial"/>
+                  <a:buChar char="•"/>
+                  <a:defRPr sz="3200" kern="1200">
+                    <a:solidFill>
+                      <a:schemeClr val="tx1"/>
+                    </a:solidFill>
+                    <a:latin typeface="+mn-lt"/>
+                    <a:ea typeface="+mn-ea"/>
+                    <a:cs typeface="+mn-cs"/>
+                  </a:defRPr>
+                </a:lvl1pPr>
+                <a:lvl2pPr marL="742950" indent="-285750" algn="l" defTabSz="457200" rtl="0" eaLnBrk="1" latinLnBrk="0" hangingPunct="1">
+                  <a:spcBef>
+                    <a:spcPct val="20000"/>
+                  </a:spcBef>
+                  <a:buFont typeface="Arial"/>
+                  <a:buChar char="–"/>
+                  <a:defRPr sz="2800" kern="1200">
+                    <a:solidFill>
+                      <a:schemeClr val="tx1"/>
+                    </a:solidFill>
+                    <a:latin typeface="+mn-lt"/>
+                    <a:ea typeface="+mn-ea"/>
+                    <a:cs typeface="+mn-cs"/>
+                  </a:defRPr>
+                </a:lvl2pPr>
+                <a:lvl3pPr marL="1143000" indent="-228600" algn="l" defTabSz="457200" rtl="0" eaLnBrk="1" latinLnBrk="0" hangingPunct="1">
+                  <a:spcBef>
+                    <a:spcPct val="20000"/>
+                  </a:spcBef>
+                  <a:buFont typeface="Arial"/>
+                  <a:buChar char="•"/>
+                  <a:defRPr sz="2400" kern="1200">
+                    <a:solidFill>
+                      <a:schemeClr val="tx1"/>
+                    </a:solidFill>
+                    <a:latin typeface="+mn-lt"/>
+                    <a:ea typeface="+mn-ea"/>
+                    <a:cs typeface="+mn-cs"/>
+                  </a:defRPr>
+                </a:lvl3pPr>
+                <a:lvl4pPr marL="1600200" indent="-228600" algn="l" defTabSz="457200" rtl="0" eaLnBrk="1" latinLnBrk="0" hangingPunct="1">
+                  <a:spcBef>
+                    <a:spcPct val="20000"/>
+                  </a:spcBef>
+                  <a:buFont typeface="Arial"/>
+                  <a:buChar char="–"/>
+                  <a:defRPr sz="2000" kern="1200">
+                    <a:solidFill>
+                      <a:schemeClr val="tx1"/>
+                    </a:solidFill>
+                    <a:latin typeface="+mn-lt"/>
+                    <a:ea typeface="+mn-ea"/>
+                    <a:cs typeface="+mn-cs"/>
+                  </a:defRPr>
+                </a:lvl4pPr>
+                <a:lvl5pPr marL="2057400" indent="-228600" algn="l" defTabSz="457200" rtl="0" eaLnBrk="1" latinLnBrk="0" hangingPunct="1">
+                  <a:spcBef>
+                    <a:spcPct val="20000"/>
+                  </a:spcBef>
+                  <a:buFont typeface="Arial"/>
+                  <a:buChar char="»"/>
+                  <a:defRPr sz="2000" kern="1200">
+                    <a:solidFill>
+                      <a:schemeClr val="tx1"/>
+                    </a:solidFill>
+                    <a:latin typeface="+mn-lt"/>
+                    <a:ea typeface="+mn-ea"/>
+                    <a:cs typeface="+mn-cs"/>
+                  </a:defRPr>
+                </a:lvl5pPr>
+                <a:lvl6pPr marL="2514600" indent="-228600" algn="l" defTabSz="457200" rtl="0" eaLnBrk="1" latinLnBrk="0" hangingPunct="1">
+                  <a:spcBef>
+                    <a:spcPct val="20000"/>
+                  </a:spcBef>
+                  <a:buFont typeface="Arial"/>
+                  <a:buChar char="•"/>
+                  <a:defRPr sz="2000" kern="1200">
+                    <a:solidFill>
+                      <a:schemeClr val="tx1"/>
+                    </a:solidFill>
+                    <a:latin typeface="+mn-lt"/>
+                    <a:ea typeface="+mn-ea"/>
+                    <a:cs typeface="+mn-cs"/>
+                  </a:defRPr>
+                </a:lvl6pPr>
+                <a:lvl7pPr marL="2971800" indent="-228600" algn="l" defTabSz="457200" rtl="0" eaLnBrk="1" latinLnBrk="0" hangingPunct="1">
+                  <a:spcBef>
+                    <a:spcPct val="20000"/>
+                  </a:spcBef>
+                  <a:buFont typeface="Arial"/>
+                  <a:buChar char="•"/>
+                  <a:defRPr sz="2000" kern="1200">
+                    <a:solidFill>
+                      <a:schemeClr val="tx1"/>
+                    </a:solidFill>
+                    <a:latin typeface="+mn-lt"/>
+                    <a:ea typeface="+mn-ea"/>
+                    <a:cs typeface="+mn-cs"/>
+                  </a:defRPr>
+                </a:lvl7pPr>
+                <a:lvl8pPr marL="3429000" indent="-228600" algn="l" defTabSz="457200" rtl="0" eaLnBrk="1" latinLnBrk="0" hangingPunct="1">
+                  <a:spcBef>
+                    <a:spcPct val="20000"/>
+                  </a:spcBef>
+                  <a:buFont typeface="Arial"/>
+                  <a:buChar char="•"/>
+                  <a:defRPr sz="2000" kern="1200">
+                    <a:solidFill>
+                      <a:schemeClr val="tx1"/>
+                    </a:solidFill>
+                    <a:latin typeface="+mn-lt"/>
+                    <a:ea typeface="+mn-ea"/>
+                    <a:cs typeface="+mn-cs"/>
+                  </a:defRPr>
+                </a:lvl8pPr>
+                <a:lvl9pPr marL="3886200" indent="-228600" algn="l" defTabSz="457200" rtl="0" eaLnBrk="1" latinLnBrk="0" hangingPunct="1">
+                  <a:spcBef>
+                    <a:spcPct val="20000"/>
+                  </a:spcBef>
+                  <a:buFont typeface="Arial"/>
+                  <a:buChar char="•"/>
+                  <a:defRPr sz="2000" kern="1200">
+                    <a:solidFill>
+                      <a:schemeClr val="tx1"/>
+                    </a:solidFill>
+                    <a:latin typeface="+mn-lt"/>
+                    <a:ea typeface="+mn-ea"/>
+                    <a:cs typeface="+mn-cs"/>
+                  </a:defRPr>
+                </a:lvl9pPr>
+              </a:lstStyle>
+              <a:p>
+                <a:pPr marL="0" indent="0">
+                  <a:buFont typeface="Arial"/>
+                  <a:buNone/>
+                </a:pPr>
+                <a14:m>
+                  <m:oMathPara xmlns:m="http://schemas.openxmlformats.org/officeDocument/2006/math">
+                    <m:oMathParaPr>
+                      <m:jc m:val="centerGroup"/>
+                    </m:oMathParaPr>
+                    <m:oMath xmlns:m="http://schemas.openxmlformats.org/officeDocument/2006/math">
+                      <m:sSub>
+                        <m:sSubPr>
+                          <m:ctrlPr>
+                            <a:rPr lang="en-US" sz="1800" b="1" i="1" dirty="0" smtClean="0">
+                              <a:solidFill>
+                                <a:srgbClr val="13294B"/>
+                              </a:solidFill>
+                              <a:latin typeface="Cambria Math" panose="02040503050406030204" pitchFamily="18" charset="0"/>
+                              <a:cs typeface="Calibri" charset="0"/>
+                            </a:rPr>
+                          </m:ctrlPr>
+                        </m:sSubPr>
+                        <m:e>
+                          <m:r>
+                            <a:rPr lang="en-US" sz="1800" b="1" i="1" dirty="0" smtClean="0">
+                              <a:solidFill>
+                                <a:srgbClr val="13294B"/>
+                              </a:solidFill>
+                              <a:latin typeface="Cambria Math" panose="02040503050406030204" pitchFamily="18" charset="0"/>
+                              <a:cs typeface="Calibri" charset="0"/>
+                            </a:rPr>
+                            <m:t>𝑫</m:t>
+                          </m:r>
+                        </m:e>
+                        <m:sub>
+                          <m:r>
+                            <a:rPr lang="en-US" sz="1800" b="1" i="1" dirty="0" smtClean="0">
+                              <a:solidFill>
+                                <a:srgbClr val="13294B"/>
+                              </a:solidFill>
+                              <a:latin typeface="Cambria Math" panose="02040503050406030204" pitchFamily="18" charset="0"/>
+                              <a:cs typeface="Calibri" charset="0"/>
+                            </a:rPr>
+                            <m:t>𝑷</m:t>
+                          </m:r>
+                        </m:sub>
+                      </m:sSub>
+                    </m:oMath>
+                  </m:oMathPara>
+                </a14:m>
+                <a:endParaRPr lang="en-US" sz="1800" b="1" i="1" dirty="0"/>
+              </a:p>
+            </p:txBody>
+          </p:sp>
+        </mc:Choice>
+        <mc:Fallback xmlns="">
+          <p:sp>
+            <p:nvSpPr>
+              <p:cNvPr id="12" name="Content Placeholder 2">
+                <a:extLst>
+                  <a:ext uri="{FF2B5EF4-FFF2-40B4-BE49-F238E27FC236}">
+                    <a16:creationId xmlns:a16="http://schemas.microsoft.com/office/drawing/2014/main" id="{5BD448EF-EE69-4527-899B-A822A4FD9FA7}"/>
+                  </a:ext>
+                </a:extLst>
+              </p:cNvPr>
+              <p:cNvSpPr txBox="1">
+                <a:spLocks noRot="1" noChangeAspect="1" noMove="1" noResize="1" noEditPoints="1" noAdjustHandles="1" noChangeArrowheads="1" noChangeShapeType="1" noTextEdit="1"/>
+              </p:cNvSpPr>
+              <p:nvPr/>
+            </p:nvSpPr>
+            <p:spPr>
+              <a:xfrm>
+                <a:off x="7501450" y="1858128"/>
+                <a:ext cx="463151" cy="253763"/>
+              </a:xfrm>
+              <a:prstGeom prst="rect">
+                <a:avLst/>
+              </a:prstGeom>
+              <a:blipFill>
+                <a:blip r:embed="rId8"/>
+                <a:stretch>
+                  <a:fillRect b="-48780"/>
+                </a:stretch>
+              </a:blipFill>
+            </p:spPr>
+            <p:txBody>
+              <a:bodyPr/>
+              <a:lstStyle/>
+              <a:p>
+                <a:r>
+                  <a:rPr lang="en-US">
+                    <a:noFill/>
+                  </a:rPr>
+                  <a:t> </a:t>
+                </a:r>
+              </a:p>
+            </p:txBody>
+          </p:sp>
+        </mc:Fallback>
+      </mc:AlternateContent>
     </p:spTree>
     <p:extLst>
       <p:ext uri="{BB962C8B-B14F-4D97-AF65-F5344CB8AC3E}">
@@ -13997,8 +15330,8 @@
           </a:p>
         </p:txBody>
       </p:sp>
-      <mc:AlternateContent xmlns:mc="http://schemas.openxmlformats.org/markup-compatibility/2006">
-        <mc:Choice xmlns:a14="http://schemas.microsoft.com/office/drawing/2010/main" Requires="a14">
+      <mc:AlternateContent xmlns:mc="http://schemas.openxmlformats.org/markup-compatibility/2006" xmlns:a14="http://schemas.microsoft.com/office/drawing/2010/main">
+        <mc:Choice Requires="a14">
           <p:sp>
             <p:nvSpPr>
               <p:cNvPr id="6" name="Rectangle 5">
@@ -14211,7 +15544,7 @@
             </p:txBody>
           </p:sp>
         </mc:Choice>
-        <mc:Fallback>
+        <mc:Fallback xmlns="">
           <p:sp>
             <p:nvSpPr>
               <p:cNvPr id="6" name="Rectangle 5">
@@ -14523,8 +15856,8 @@
           </a:p>
         </p:txBody>
       </p:sp>
-      <mc:AlternateContent xmlns:mc="http://schemas.openxmlformats.org/markup-compatibility/2006">
-        <mc:Choice xmlns:a14="http://schemas.microsoft.com/office/drawing/2010/main" Requires="a14">
+      <mc:AlternateContent xmlns:mc="http://schemas.openxmlformats.org/markup-compatibility/2006" xmlns:a14="http://schemas.microsoft.com/office/drawing/2010/main">
+        <mc:Choice Requires="a14">
           <p:sp>
             <p:nvSpPr>
               <p:cNvPr id="9" name="Rectangle 8">
@@ -14612,7 +15945,7 @@
             </p:txBody>
           </p:sp>
         </mc:Choice>
-        <mc:Fallback>
+        <mc:Fallback xmlns="">
           <p:sp>
             <p:nvSpPr>
               <p:cNvPr id="9" name="Rectangle 8">
@@ -14657,8 +15990,8 @@
           </p:sp>
         </mc:Fallback>
       </mc:AlternateContent>
-      <mc:AlternateContent xmlns:mc="http://schemas.openxmlformats.org/markup-compatibility/2006">
-        <mc:Choice xmlns:a14="http://schemas.microsoft.com/office/drawing/2010/main" Requires="a14">
+      <mc:AlternateContent xmlns:mc="http://schemas.openxmlformats.org/markup-compatibility/2006" xmlns:a14="http://schemas.microsoft.com/office/drawing/2010/main">
+        <mc:Choice Requires="a14">
           <p:sp>
             <p:nvSpPr>
               <p:cNvPr id="13" name="Rectangle 12">
@@ -14726,7 +16059,7 @@
             </p:txBody>
           </p:sp>
         </mc:Choice>
-        <mc:Fallback>
+        <mc:Fallback xmlns="">
           <p:sp>
             <p:nvSpPr>
               <p:cNvPr id="13" name="Rectangle 12">
@@ -14812,8 +16145,8 @@
           </a:p>
         </p:txBody>
       </p:sp>
-      <mc:AlternateContent xmlns:mc="http://schemas.openxmlformats.org/markup-compatibility/2006">
-        <mc:Choice xmlns:a14="http://schemas.microsoft.com/office/drawing/2010/main" Requires="a14">
+      <mc:AlternateContent xmlns:mc="http://schemas.openxmlformats.org/markup-compatibility/2006" xmlns:a14="http://schemas.microsoft.com/office/drawing/2010/main">
+        <mc:Choice Requires="a14">
           <p:sp>
             <p:nvSpPr>
               <p:cNvPr id="15" name="Rectangle 14">
@@ -14907,7 +16240,7 @@
             </p:txBody>
           </p:sp>
         </mc:Choice>
-        <mc:Fallback>
+        <mc:Fallback xmlns="">
           <p:sp>
             <p:nvSpPr>
               <p:cNvPr id="15" name="Rectangle 14">
@@ -14934,6 +16267,318 @@
                 <a:blip r:embed="rId6"/>
                 <a:stretch>
                   <a:fillRect l="-1422" t="-10000" b="-26667"/>
+                </a:stretch>
+              </a:blipFill>
+            </p:spPr>
+            <p:txBody>
+              <a:bodyPr/>
+              <a:lstStyle/>
+              <a:p>
+                <a:r>
+                  <a:rPr lang="en-US">
+                    <a:noFill/>
+                  </a:rPr>
+                  <a:t> </a:t>
+                </a:r>
+              </a:p>
+            </p:txBody>
+          </p:sp>
+        </mc:Fallback>
+      </mc:AlternateContent>
+      <p:pic>
+        <p:nvPicPr>
+          <p:cNvPr id="17" name="Picture 2" descr="Related image">
+            <a:extLst>
+              <a:ext uri="{FF2B5EF4-FFF2-40B4-BE49-F238E27FC236}">
+                <a16:creationId xmlns:a16="http://schemas.microsoft.com/office/drawing/2014/main" id="{8E48A471-4040-4B45-92A3-C23ABED92909}"/>
+              </a:ext>
+            </a:extLst>
+          </p:cNvPr>
+          <p:cNvPicPr>
+            <a:picLocks noChangeAspect="1" noChangeArrowheads="1"/>
+          </p:cNvPicPr>
+          <p:nvPr/>
+        </p:nvPicPr>
+        <p:blipFill>
+          <a:blip r:embed="rId7">
+            <a:extLst>
+              <a:ext uri="{28A0092B-C50C-407E-A947-70E740481C1C}">
+                <a14:useLocalDpi xmlns:a14="http://schemas.microsoft.com/office/drawing/2010/main" val="0"/>
+              </a:ext>
+            </a:extLst>
+          </a:blip>
+          <a:srcRect/>
+          <a:stretch>
+            <a:fillRect/>
+          </a:stretch>
+        </p:blipFill>
+        <p:spPr bwMode="auto">
+          <a:xfrm>
+            <a:off x="7312882" y="1017071"/>
+            <a:ext cx="919220" cy="919220"/>
+          </a:xfrm>
+          <a:prstGeom prst="rect">
+            <a:avLst/>
+          </a:prstGeom>
+          <a:noFill/>
+          <a:extLst>
+            <a:ext uri="{909E8E84-426E-40DD-AFC4-6F175D3DCCD1}">
+              <a14:hiddenFill xmlns:a14="http://schemas.microsoft.com/office/drawing/2010/main">
+                <a:solidFill>
+                  <a:srgbClr val="FFFFFF"/>
+                </a:solidFill>
+              </a14:hiddenFill>
+            </a:ext>
+          </a:extLst>
+        </p:spPr>
+      </p:pic>
+      <mc:AlternateContent xmlns:mc="http://schemas.openxmlformats.org/markup-compatibility/2006" xmlns:a14="http://schemas.microsoft.com/office/drawing/2010/main">
+        <mc:Choice Requires="a14">
+          <p:sp>
+            <p:nvSpPr>
+              <p:cNvPr id="18" name="Content Placeholder 2">
+                <a:extLst>
+                  <a:ext uri="{FF2B5EF4-FFF2-40B4-BE49-F238E27FC236}">
+                    <a16:creationId xmlns:a16="http://schemas.microsoft.com/office/drawing/2014/main" id="{54AEA0B3-857E-4A3A-B34A-B4D4ABDFB3AC}"/>
+                  </a:ext>
+                </a:extLst>
+              </p:cNvPr>
+              <p:cNvSpPr txBox="1">
+                <a:spLocks/>
+              </p:cNvSpPr>
+              <p:nvPr/>
+            </p:nvSpPr>
+            <p:spPr>
+              <a:xfrm>
+                <a:off x="7501450" y="1858128"/>
+                <a:ext cx="463151" cy="253763"/>
+              </a:xfrm>
+              <a:prstGeom prst="rect">
+                <a:avLst/>
+              </a:prstGeom>
+            </p:spPr>
+            <p:txBody>
+              <a:bodyPr/>
+              <a:lstStyle>
+                <a:lvl1pPr marL="342900" indent="-342900" algn="l" defTabSz="457200" rtl="0" eaLnBrk="1" latinLnBrk="0" hangingPunct="1">
+                  <a:spcBef>
+                    <a:spcPct val="20000"/>
+                  </a:spcBef>
+                  <a:buFont typeface="Arial"/>
+                  <a:buChar char="•"/>
+                  <a:defRPr sz="3200" kern="1200">
+                    <a:solidFill>
+                      <a:schemeClr val="tx1"/>
+                    </a:solidFill>
+                    <a:latin typeface="+mn-lt"/>
+                    <a:ea typeface="+mn-ea"/>
+                    <a:cs typeface="+mn-cs"/>
+                  </a:defRPr>
+                </a:lvl1pPr>
+                <a:lvl2pPr marL="742950" indent="-285750" algn="l" defTabSz="457200" rtl="0" eaLnBrk="1" latinLnBrk="0" hangingPunct="1">
+                  <a:spcBef>
+                    <a:spcPct val="20000"/>
+                  </a:spcBef>
+                  <a:buFont typeface="Arial"/>
+                  <a:buChar char="–"/>
+                  <a:defRPr sz="2800" kern="1200">
+                    <a:solidFill>
+                      <a:schemeClr val="tx1"/>
+                    </a:solidFill>
+                    <a:latin typeface="+mn-lt"/>
+                    <a:ea typeface="+mn-ea"/>
+                    <a:cs typeface="+mn-cs"/>
+                  </a:defRPr>
+                </a:lvl2pPr>
+                <a:lvl3pPr marL="1143000" indent="-228600" algn="l" defTabSz="457200" rtl="0" eaLnBrk="1" latinLnBrk="0" hangingPunct="1">
+                  <a:spcBef>
+                    <a:spcPct val="20000"/>
+                  </a:spcBef>
+                  <a:buFont typeface="Arial"/>
+                  <a:buChar char="•"/>
+                  <a:defRPr sz="2400" kern="1200">
+                    <a:solidFill>
+                      <a:schemeClr val="tx1"/>
+                    </a:solidFill>
+                    <a:latin typeface="+mn-lt"/>
+                    <a:ea typeface="+mn-ea"/>
+                    <a:cs typeface="+mn-cs"/>
+                  </a:defRPr>
+                </a:lvl3pPr>
+                <a:lvl4pPr marL="1600200" indent="-228600" algn="l" defTabSz="457200" rtl="0" eaLnBrk="1" latinLnBrk="0" hangingPunct="1">
+                  <a:spcBef>
+                    <a:spcPct val="20000"/>
+                  </a:spcBef>
+                  <a:buFont typeface="Arial"/>
+                  <a:buChar char="–"/>
+                  <a:defRPr sz="2000" kern="1200">
+                    <a:solidFill>
+                      <a:schemeClr val="tx1"/>
+                    </a:solidFill>
+                    <a:latin typeface="+mn-lt"/>
+                    <a:ea typeface="+mn-ea"/>
+                    <a:cs typeface="+mn-cs"/>
+                  </a:defRPr>
+                </a:lvl4pPr>
+                <a:lvl5pPr marL="2057400" indent="-228600" algn="l" defTabSz="457200" rtl="0" eaLnBrk="1" latinLnBrk="0" hangingPunct="1">
+                  <a:spcBef>
+                    <a:spcPct val="20000"/>
+                  </a:spcBef>
+                  <a:buFont typeface="Arial"/>
+                  <a:buChar char="»"/>
+                  <a:defRPr sz="2000" kern="1200">
+                    <a:solidFill>
+                      <a:schemeClr val="tx1"/>
+                    </a:solidFill>
+                    <a:latin typeface="+mn-lt"/>
+                    <a:ea typeface="+mn-ea"/>
+                    <a:cs typeface="+mn-cs"/>
+                  </a:defRPr>
+                </a:lvl5pPr>
+                <a:lvl6pPr marL="2514600" indent="-228600" algn="l" defTabSz="457200" rtl="0" eaLnBrk="1" latinLnBrk="0" hangingPunct="1">
+                  <a:spcBef>
+                    <a:spcPct val="20000"/>
+                  </a:spcBef>
+                  <a:buFont typeface="Arial"/>
+                  <a:buChar char="•"/>
+                  <a:defRPr sz="2000" kern="1200">
+                    <a:solidFill>
+                      <a:schemeClr val="tx1"/>
+                    </a:solidFill>
+                    <a:latin typeface="+mn-lt"/>
+                    <a:ea typeface="+mn-ea"/>
+                    <a:cs typeface="+mn-cs"/>
+                  </a:defRPr>
+                </a:lvl6pPr>
+                <a:lvl7pPr marL="2971800" indent="-228600" algn="l" defTabSz="457200" rtl="0" eaLnBrk="1" latinLnBrk="0" hangingPunct="1">
+                  <a:spcBef>
+                    <a:spcPct val="20000"/>
+                  </a:spcBef>
+                  <a:buFont typeface="Arial"/>
+                  <a:buChar char="•"/>
+                  <a:defRPr sz="2000" kern="1200">
+                    <a:solidFill>
+                      <a:schemeClr val="tx1"/>
+                    </a:solidFill>
+                    <a:latin typeface="+mn-lt"/>
+                    <a:ea typeface="+mn-ea"/>
+                    <a:cs typeface="+mn-cs"/>
+                  </a:defRPr>
+                </a:lvl7pPr>
+                <a:lvl8pPr marL="3429000" indent="-228600" algn="l" defTabSz="457200" rtl="0" eaLnBrk="1" latinLnBrk="0" hangingPunct="1">
+                  <a:spcBef>
+                    <a:spcPct val="20000"/>
+                  </a:spcBef>
+                  <a:buFont typeface="Arial"/>
+                  <a:buChar char="•"/>
+                  <a:defRPr sz="2000" kern="1200">
+                    <a:solidFill>
+                      <a:schemeClr val="tx1"/>
+                    </a:solidFill>
+                    <a:latin typeface="+mn-lt"/>
+                    <a:ea typeface="+mn-ea"/>
+                    <a:cs typeface="+mn-cs"/>
+                  </a:defRPr>
+                </a:lvl8pPr>
+                <a:lvl9pPr marL="3886200" indent="-228600" algn="l" defTabSz="457200" rtl="0" eaLnBrk="1" latinLnBrk="0" hangingPunct="1">
+                  <a:spcBef>
+                    <a:spcPct val="20000"/>
+                  </a:spcBef>
+                  <a:buFont typeface="Arial"/>
+                  <a:buChar char="•"/>
+                  <a:defRPr sz="2000" kern="1200">
+                    <a:solidFill>
+                      <a:schemeClr val="tx1"/>
+                    </a:solidFill>
+                    <a:latin typeface="+mn-lt"/>
+                    <a:ea typeface="+mn-ea"/>
+                    <a:cs typeface="+mn-cs"/>
+                  </a:defRPr>
+                </a:lvl9pPr>
+              </a:lstStyle>
+              <a:p>
+                <a:pPr marL="0" indent="0">
+                  <a:buFont typeface="Arial"/>
+                  <a:buNone/>
+                </a:pPr>
+                <a14:m>
+                  <m:oMathPara xmlns:m="http://schemas.openxmlformats.org/officeDocument/2006/math">
+                    <m:oMathParaPr>
+                      <m:jc m:val="centerGroup"/>
+                    </m:oMathParaPr>
+                    <m:oMath xmlns:m="http://schemas.openxmlformats.org/officeDocument/2006/math">
+                      <m:sSub>
+                        <m:sSubPr>
+                          <m:ctrlPr>
+                            <a:rPr lang="en-US" sz="1800" b="1" i="1" dirty="0" smtClean="0">
+                              <a:solidFill>
+                                <a:srgbClr val="13294B"/>
+                              </a:solidFill>
+                              <a:latin typeface="Cambria Math" panose="02040503050406030204" pitchFamily="18" charset="0"/>
+                              <a:cs typeface="Calibri" charset="0"/>
+                            </a:rPr>
+                          </m:ctrlPr>
+                        </m:sSubPr>
+                        <m:e>
+                          <m:r>
+                            <a:rPr lang="en-US" sz="1800" b="1" i="1" dirty="0" smtClean="0">
+                              <a:solidFill>
+                                <a:srgbClr val="13294B"/>
+                              </a:solidFill>
+                              <a:latin typeface="Cambria Math" panose="02040503050406030204" pitchFamily="18" charset="0"/>
+                              <a:cs typeface="Calibri" charset="0"/>
+                            </a:rPr>
+                            <m:t>𝑫</m:t>
+                          </m:r>
+                        </m:e>
+                        <m:sub>
+                          <m:r>
+                            <a:rPr lang="en-US" sz="1800" b="1" i="1" dirty="0" smtClean="0">
+                              <a:solidFill>
+                                <a:srgbClr val="13294B"/>
+                              </a:solidFill>
+                              <a:latin typeface="Cambria Math" panose="02040503050406030204" pitchFamily="18" charset="0"/>
+                              <a:cs typeface="Calibri" charset="0"/>
+                            </a:rPr>
+                            <m:t>𝑺</m:t>
+                          </m:r>
+                        </m:sub>
+                      </m:sSub>
+                    </m:oMath>
+                  </m:oMathPara>
+                </a14:m>
+                <a:endParaRPr lang="en-US" sz="1800" b="1" i="1" dirty="0"/>
+              </a:p>
+            </p:txBody>
+          </p:sp>
+        </mc:Choice>
+        <mc:Fallback xmlns="">
+          <p:sp>
+            <p:nvSpPr>
+              <p:cNvPr id="18" name="Content Placeholder 2">
+                <a:extLst>
+                  <a:ext uri="{FF2B5EF4-FFF2-40B4-BE49-F238E27FC236}">
+                    <a16:creationId xmlns:a16="http://schemas.microsoft.com/office/drawing/2014/main" id="{54AEA0B3-857E-4A3A-B34A-B4D4ABDFB3AC}"/>
+                  </a:ext>
+                </a:extLst>
+              </p:cNvPr>
+              <p:cNvSpPr txBox="1">
+                <a:spLocks noRot="1" noChangeAspect="1" noMove="1" noResize="1" noEditPoints="1" noAdjustHandles="1" noChangeArrowheads="1" noChangeShapeType="1" noTextEdit="1"/>
+              </p:cNvSpPr>
+              <p:nvPr/>
+            </p:nvSpPr>
+            <p:spPr>
+              <a:xfrm>
+                <a:off x="7501450" y="1858128"/>
+                <a:ext cx="463151" cy="253763"/>
+              </a:xfrm>
+              <a:prstGeom prst="rect">
+                <a:avLst/>
+              </a:prstGeom>
+              <a:blipFill>
+                <a:blip r:embed="rId8"/>
+                <a:stretch>
+                  <a:fillRect b="-48780"/>
                 </a:stretch>
               </a:blipFill>
             </p:spPr>
@@ -15157,7 +16802,7 @@
                 <a:latin typeface="Calibri" charset="0"/>
                 <a:cs typeface="Calibri" charset="0"/>
               </a:rPr>
-              <a:t>Machine learning task measures</a:t>
+              <a:t>Machine learning task metric</a:t>
             </a:r>
           </a:p>
         </p:txBody>
@@ -16108,7 +17753,7 @@
         <p:spPr>
           <a:xfrm>
             <a:off x="380999" y="3599911"/>
-            <a:ext cx="7830845" cy="3139321"/>
+            <a:ext cx="8061665" cy="3139321"/>
           </a:xfrm>
           <a:prstGeom prst="rect">
             <a:avLst/>
@@ -16177,7 +17822,7 @@
                 <a:latin typeface="Calibri" charset="0"/>
                 <a:cs typeface="Calibri" charset="0"/>
               </a:rPr>
-              <a:t>: When there is a strong consensus among teachers, the label they almost all agree on does not depend on the model learned by any given teacher. The original PATE framework </a:t>
+              <a:t>: When there is a strong consensus among teachers, the label they almost all agree on does not depend on the model learned by any given specific teacher. The original PATE framework </a:t>
             </a:r>
             <a:r>
               <a:rPr lang="en-US" b="1" dirty="0">
@@ -16232,7 +17877,7 @@
                 <a:latin typeface="Calibri" charset="0"/>
                 <a:cs typeface="Calibri" charset="0"/>
               </a:rPr>
-              <a:t>: The student model only sees public data and privacy-preserving labels. And trained itself in a semi-supervised way, because the author notes each ensemble prediction increase the privacy cost.</a:t>
+              <a:t>: The student model only sees public data and privacy-preserving labels from teachers’ consensus. And trained itself in a semi-supervised way, because the author notes each ensemble prediction increase the privacy cost.</a:t>
             </a:r>
           </a:p>
         </p:txBody>
@@ -16822,7 +18467,7 @@
                 <a:latin typeface="Calibri" charset="0"/>
                 <a:cs typeface="Calibri" charset="0"/>
               </a:rPr>
-              <a:t>Gaussian distribution is more concentrated then Laplace distribution. Increase the aggregation utility when number of classes is large</a:t>
+              <a:t>Gaussian distribution is more concentrated than Laplace distribution. Increase the aggregation utility when number of classes is large.</a:t>
             </a:r>
           </a:p>
         </p:txBody>
@@ -16862,7 +18507,7 @@
                 <a:latin typeface="Calibri" charset="0"/>
                 <a:cs typeface="Calibri" charset="0"/>
               </a:rPr>
-              <a:t>Select student queries which are worthwhile answering</a:t>
+              <a:t>Select student queries which are worthwhile answering.</a:t>
             </a:r>
           </a:p>
         </p:txBody>
@@ -17054,87 +18699,83 @@
           </a:p>
         </p:txBody>
       </p:sp>
-      <p:grpSp>
-        <p:nvGrpSpPr>
-          <p:cNvPr id="4" name="Group 3">
+      <p:pic>
+        <p:nvPicPr>
+          <p:cNvPr id="5" name="Picture 4">
             <a:extLst>
               <a:ext uri="{FF2B5EF4-FFF2-40B4-BE49-F238E27FC236}">
-                <a16:creationId xmlns:a16="http://schemas.microsoft.com/office/drawing/2014/main" id="{59A5F6DF-2618-496C-B848-6F157B8D241D}"/>
+                <a16:creationId xmlns:a16="http://schemas.microsoft.com/office/drawing/2014/main" id="{58EDB19D-C499-4262-A9C0-7D77621B2452}"/>
               </a:ext>
             </a:extLst>
           </p:cNvPr>
-          <p:cNvGrpSpPr/>
+          <p:cNvPicPr>
+            <a:picLocks noChangeAspect="1"/>
+          </p:cNvPicPr>
           <p:nvPr/>
-        </p:nvGrpSpPr>
-        <p:grpSpPr>
+        </p:nvPicPr>
+        <p:blipFill>
+          <a:blip r:embed="rId3"/>
+          <a:stretch>
+            <a:fillRect/>
+          </a:stretch>
+        </p:blipFill>
+        <p:spPr>
           <a:xfrm>
-            <a:off x="945470" y="2795557"/>
-            <a:ext cx="7097699" cy="1571844"/>
-            <a:chOff x="945470" y="2795557"/>
-            <a:chExt cx="7097699" cy="1571844"/>
+            <a:off x="514166" y="2775202"/>
+            <a:ext cx="7324078" cy="1739944"/>
           </a:xfrm>
-        </p:grpSpPr>
-        <p:pic>
-          <p:nvPicPr>
-            <p:cNvPr id="2" name="Picture 1">
-              <a:extLst>
-                <a:ext uri="{FF2B5EF4-FFF2-40B4-BE49-F238E27FC236}">
-                  <a16:creationId xmlns:a16="http://schemas.microsoft.com/office/drawing/2014/main" id="{A8ECFA12-F2ED-4D5B-95CC-B1A46CE055E2}"/>
-                </a:ext>
-              </a:extLst>
-            </p:cNvPr>
-            <p:cNvPicPr>
-              <a:picLocks noChangeAspect="1"/>
-            </p:cNvPicPr>
-            <p:nvPr/>
-          </p:nvPicPr>
-          <p:blipFill>
-            <a:blip r:embed="rId3"/>
-            <a:stretch>
-              <a:fillRect/>
-            </a:stretch>
-          </p:blipFill>
-          <p:spPr>
-            <a:xfrm>
-              <a:off x="945470" y="2795557"/>
-              <a:ext cx="6649378" cy="1381318"/>
-            </a:xfrm>
-            <a:prstGeom prst="rect">
-              <a:avLst/>
-            </a:prstGeom>
-          </p:spPr>
-        </p:pic>
-        <p:pic>
-          <p:nvPicPr>
-            <p:cNvPr id="3" name="Picture 2">
-              <a:extLst>
-                <a:ext uri="{FF2B5EF4-FFF2-40B4-BE49-F238E27FC236}">
-                  <a16:creationId xmlns:a16="http://schemas.microsoft.com/office/drawing/2014/main" id="{37C5399C-D479-48EC-A35C-919605188640}"/>
-                </a:ext>
-              </a:extLst>
-            </p:cNvPr>
-            <p:cNvPicPr>
-              <a:picLocks noChangeAspect="1"/>
-            </p:cNvPicPr>
-            <p:nvPr/>
-          </p:nvPicPr>
-          <p:blipFill>
-            <a:blip r:embed="rId4"/>
-            <a:stretch>
-              <a:fillRect/>
-            </a:stretch>
-          </p:blipFill>
-          <p:spPr>
-            <a:xfrm>
-              <a:off x="5947949" y="3986348"/>
-              <a:ext cx="2095220" cy="381053"/>
-            </a:xfrm>
-            <a:prstGeom prst="rect">
-              <a:avLst/>
-            </a:prstGeom>
-          </p:spPr>
-        </p:pic>
-      </p:grpSp>
+          <a:prstGeom prst="rect">
+            <a:avLst/>
+          </a:prstGeom>
+        </p:spPr>
+      </p:pic>
+      <p:cxnSp>
+        <p:nvCxnSpPr>
+          <p:cNvPr id="9" name="Straight Connector 8">
+            <a:extLst>
+              <a:ext uri="{FF2B5EF4-FFF2-40B4-BE49-F238E27FC236}">
+                <a16:creationId xmlns:a16="http://schemas.microsoft.com/office/drawing/2014/main" id="{8328A509-4BB2-465D-91C7-DCC0945A266F}"/>
+              </a:ext>
+            </a:extLst>
+          </p:cNvPr>
+          <p:cNvCxnSpPr>
+            <a:cxnSpLocks/>
+          </p:cNvCxnSpPr>
+          <p:nvPr/>
+        </p:nvCxnSpPr>
+        <p:spPr>
+          <a:xfrm>
+            <a:off x="4119241" y="3790766"/>
+            <a:ext cx="470517" cy="0"/>
+          </a:xfrm>
+          <a:prstGeom prst="line">
+            <a:avLst/>
+          </a:prstGeom>
+          <a:ln w="28575" cap="flat" cmpd="sng" algn="ctr">
+            <a:solidFill>
+              <a:srgbClr val="FF0000"/>
+            </a:solidFill>
+            <a:prstDash val="dash"/>
+            <a:round/>
+            <a:headEnd type="none" w="med" len="med"/>
+            <a:tailEnd type="none" w="med" len="med"/>
+          </a:ln>
+        </p:spPr>
+        <p:style>
+          <a:lnRef idx="0">
+            <a:scrgbClr r="0" g="0" b="0"/>
+          </a:lnRef>
+          <a:fillRef idx="0">
+            <a:scrgbClr r="0" g="0" b="0"/>
+          </a:fillRef>
+          <a:effectRef idx="0">
+            <a:scrgbClr r="0" g="0" b="0"/>
+          </a:effectRef>
+          <a:fontRef idx="minor">
+            <a:schemeClr val="tx1"/>
+          </a:fontRef>
+        </p:style>
+      </p:cxnSp>
     </p:spTree>
     <p:extLst>
       <p:ext uri="{BB962C8B-B14F-4D97-AF65-F5344CB8AC3E}">
@@ -17272,6 +18913,53 @@
           </a:prstGeom>
         </p:spPr>
       </p:pic>
+      <p:cxnSp>
+        <p:nvCxnSpPr>
+          <p:cNvPr id="4" name="Straight Connector 3">
+            <a:extLst>
+              <a:ext uri="{FF2B5EF4-FFF2-40B4-BE49-F238E27FC236}">
+                <a16:creationId xmlns:a16="http://schemas.microsoft.com/office/drawing/2014/main" id="{CC6A35AD-0E9D-4B5C-B65F-500A9895BB1C}"/>
+              </a:ext>
+            </a:extLst>
+          </p:cNvPr>
+          <p:cNvCxnSpPr>
+            <a:cxnSpLocks/>
+          </p:cNvCxnSpPr>
+          <p:nvPr/>
+        </p:nvCxnSpPr>
+        <p:spPr>
+          <a:xfrm>
+            <a:off x="1180730" y="4403325"/>
+            <a:ext cx="2379216" cy="0"/>
+          </a:xfrm>
+          <a:prstGeom prst="line">
+            <a:avLst/>
+          </a:prstGeom>
+          <a:ln w="28575" cap="flat" cmpd="sng" algn="ctr">
+            <a:solidFill>
+              <a:srgbClr val="FF0000"/>
+            </a:solidFill>
+            <a:prstDash val="dash"/>
+            <a:round/>
+            <a:headEnd type="none" w="med" len="med"/>
+            <a:tailEnd type="none" w="med" len="med"/>
+          </a:ln>
+        </p:spPr>
+        <p:style>
+          <a:lnRef idx="0">
+            <a:scrgbClr r="0" g="0" b="0"/>
+          </a:lnRef>
+          <a:fillRef idx="0">
+            <a:scrgbClr r="0" g="0" b="0"/>
+          </a:fillRef>
+          <a:effectRef idx="0">
+            <a:scrgbClr r="0" g="0" b="0"/>
+          </a:effectRef>
+          <a:fontRef idx="minor">
+            <a:schemeClr val="tx1"/>
+          </a:fontRef>
+        </p:style>
+      </p:cxnSp>
     </p:spTree>
     <p:extLst>
       <p:ext uri="{BB962C8B-B14F-4D97-AF65-F5344CB8AC3E}">
@@ -17409,6 +19097,100 @@
           </a:prstGeom>
         </p:spPr>
       </p:pic>
+      <p:cxnSp>
+        <p:nvCxnSpPr>
+          <p:cNvPr id="5" name="Straight Connector 4">
+            <a:extLst>
+              <a:ext uri="{FF2B5EF4-FFF2-40B4-BE49-F238E27FC236}">
+                <a16:creationId xmlns:a16="http://schemas.microsoft.com/office/drawing/2014/main" id="{2C4B0AB0-BE5F-46CB-94CC-7B76C4973BCF}"/>
+              </a:ext>
+            </a:extLst>
+          </p:cNvPr>
+          <p:cNvCxnSpPr>
+            <a:cxnSpLocks/>
+          </p:cNvCxnSpPr>
+          <p:nvPr/>
+        </p:nvCxnSpPr>
+        <p:spPr>
+          <a:xfrm>
+            <a:off x="1269507" y="4918230"/>
+            <a:ext cx="1597981" cy="0"/>
+          </a:xfrm>
+          <a:prstGeom prst="line">
+            <a:avLst/>
+          </a:prstGeom>
+          <a:ln w="28575" cap="flat" cmpd="sng" algn="ctr">
+            <a:solidFill>
+              <a:srgbClr val="FF0000"/>
+            </a:solidFill>
+            <a:prstDash val="dash"/>
+            <a:round/>
+            <a:headEnd type="none" w="med" len="med"/>
+            <a:tailEnd type="none" w="med" len="med"/>
+          </a:ln>
+        </p:spPr>
+        <p:style>
+          <a:lnRef idx="0">
+            <a:scrgbClr r="0" g="0" b="0"/>
+          </a:lnRef>
+          <a:fillRef idx="0">
+            <a:scrgbClr r="0" g="0" b="0"/>
+          </a:fillRef>
+          <a:effectRef idx="0">
+            <a:scrgbClr r="0" g="0" b="0"/>
+          </a:effectRef>
+          <a:fontRef idx="minor">
+            <a:schemeClr val="tx1"/>
+          </a:fontRef>
+        </p:style>
+      </p:cxnSp>
+      <p:cxnSp>
+        <p:nvCxnSpPr>
+          <p:cNvPr id="7" name="Straight Connector 6">
+            <a:extLst>
+              <a:ext uri="{FF2B5EF4-FFF2-40B4-BE49-F238E27FC236}">
+                <a16:creationId xmlns:a16="http://schemas.microsoft.com/office/drawing/2014/main" id="{6E396455-3B1C-48AD-8E33-24DE872BF6E8}"/>
+              </a:ext>
+            </a:extLst>
+          </p:cNvPr>
+          <p:cNvCxnSpPr>
+            <a:cxnSpLocks/>
+          </p:cNvCxnSpPr>
+          <p:nvPr/>
+        </p:nvCxnSpPr>
+        <p:spPr>
+          <a:xfrm>
+            <a:off x="4218373" y="4290875"/>
+            <a:ext cx="371383" cy="0"/>
+          </a:xfrm>
+          <a:prstGeom prst="line">
+            <a:avLst/>
+          </a:prstGeom>
+          <a:ln w="28575" cap="flat" cmpd="sng" algn="ctr">
+            <a:solidFill>
+              <a:srgbClr val="FF0000"/>
+            </a:solidFill>
+            <a:prstDash val="dash"/>
+            <a:round/>
+            <a:headEnd type="none" w="med" len="med"/>
+            <a:tailEnd type="none" w="med" len="med"/>
+          </a:ln>
+        </p:spPr>
+        <p:style>
+          <a:lnRef idx="0">
+            <a:scrgbClr r="0" g="0" b="0"/>
+          </a:lnRef>
+          <a:fillRef idx="0">
+            <a:scrgbClr r="0" g="0" b="0"/>
+          </a:fillRef>
+          <a:effectRef idx="0">
+            <a:scrgbClr r="0" g="0" b="0"/>
+          </a:effectRef>
+          <a:fontRef idx="minor">
+            <a:schemeClr val="tx1"/>
+          </a:fontRef>
+        </p:style>
+      </p:cxnSp>
     </p:spTree>
     <p:extLst>
       <p:ext uri="{BB962C8B-B14F-4D97-AF65-F5344CB8AC3E}">
@@ -17957,7 +19739,7 @@
           <p:nvPr/>
         </p:nvPicPr>
         <p:blipFill>
-          <a:blip r:embed="rId2">
+          <a:blip r:embed="rId3">
             <a:extLst>
               <a:ext uri="{28A0092B-C50C-407E-A947-70E740481C1C}">
                 <a14:useLocalDpi xmlns:a14="http://schemas.microsoft.com/office/drawing/2010/main" val="0"/>
@@ -18197,7 +19979,7 @@
           <p:nvPr/>
         </p:nvPicPr>
         <p:blipFill>
-          <a:blip r:embed="rId3">
+          <a:blip r:embed="rId4">
             <a:extLst>
               <a:ext uri="{28A0092B-C50C-407E-A947-70E740481C1C}">
                 <a14:useLocalDpi xmlns:a14="http://schemas.microsoft.com/office/drawing/2010/main" val="0"/>
@@ -18437,7 +20219,7 @@
           <p:nvPr/>
         </p:nvPicPr>
         <p:blipFill>
-          <a:blip r:embed="rId4">
+          <a:blip r:embed="rId5">
             <a:extLst>
               <a:ext uri="{28A0092B-C50C-407E-A947-70E740481C1C}">
                 <a14:useLocalDpi xmlns:a14="http://schemas.microsoft.com/office/drawing/2010/main" val="0"/>
@@ -18484,7 +20266,7 @@
           <p:nvPr/>
         </p:nvPicPr>
         <p:blipFill>
-          <a:blip r:embed="rId5">
+          <a:blip r:embed="rId6">
             <a:extLst>
               <a:ext uri="{28A0092B-C50C-407E-A947-70E740481C1C}">
                 <a14:useLocalDpi xmlns:a14="http://schemas.microsoft.com/office/drawing/2010/main" val="0"/>
@@ -18724,7 +20506,7 @@
           <p:nvPr/>
         </p:nvPicPr>
         <p:blipFill>
-          <a:blip r:embed="rId6">
+          <a:blip r:embed="rId7">
             <a:extLst>
               <a:ext uri="{28A0092B-C50C-407E-A947-70E740481C1C}">
                 <a14:useLocalDpi xmlns:a14="http://schemas.microsoft.com/office/drawing/2010/main" val="0"/>
@@ -18771,7 +20553,7 @@
           <p:nvPr/>
         </p:nvPicPr>
         <p:blipFill>
-          <a:blip r:embed="rId7">
+          <a:blip r:embed="rId8">
             <a:extLst>
               <a:ext uri="{28A0092B-C50C-407E-A947-70E740481C1C}">
                 <a14:useLocalDpi xmlns:a14="http://schemas.microsoft.com/office/drawing/2010/main" val="0"/>
@@ -18818,7 +20600,7 @@
           <p:nvPr/>
         </p:nvPicPr>
         <p:blipFill>
-          <a:blip r:embed="rId8">
+          <a:blip r:embed="rId9">
             <a:extLst>
               <a:ext uri="{28A0092B-C50C-407E-A947-70E740481C1C}">
                 <a14:useLocalDpi xmlns:a14="http://schemas.microsoft.com/office/drawing/2010/main" val="0"/>
@@ -22474,7 +24256,27 @@
                     <a:latin typeface="Calibri" charset="0"/>
                     <a:cs typeface="Calibri" charset="0"/>
                   </a:rPr>
-                  <a:t>Privacy test 2 is identical to Privacy test 1 except is randomizes the threshold </a:t>
+                  <a:t>Privacy test 2 is identical to Privacy test 1 except i</a:t>
+                </a:r>
+                <a:r>
+                  <a:rPr lang="en-US" altLang="zh-CN" dirty="0">
+                    <a:solidFill>
+                      <a:srgbClr val="13294B"/>
+                    </a:solidFill>
+                    <a:latin typeface="Calibri" charset="0"/>
+                    <a:cs typeface="Calibri" charset="0"/>
+                  </a:rPr>
+                  <a:t>t</a:t>
+                </a:r>
+                <a:r>
+                  <a:rPr lang="en-US" dirty="0">
+                    <a:solidFill>
+                      <a:srgbClr val="13294B"/>
+                    </a:solidFill>
+                    <a:latin typeface="Calibri" charset="0"/>
+                    <a:cs typeface="Calibri" charset="0"/>
+                  </a:rPr>
+                  <a:t> randomizes the threshold </a:t>
                 </a:r>
                 <a14:m>
                   <m:oMath xmlns:m="http://schemas.openxmlformats.org/officeDocument/2006/math">
@@ -22531,7 +24333,7 @@
               <a:blipFill>
                 <a:blip r:embed="rId4"/>
                 <a:stretch>
-                  <a:fillRect l="-646" t="-8197" r="-242" b="-24590"/>
+                  <a:fillRect l="-646" t="-8197" r="-81" b="-24590"/>
                 </a:stretch>
               </a:blipFill>
             </p:spPr>
@@ -22550,6 +24352,53 @@
           </p:sp>
         </mc:Fallback>
       </mc:AlternateContent>
+      <p:cxnSp>
+        <p:nvCxnSpPr>
+          <p:cNvPr id="8" name="Straight Connector 7">
+            <a:extLst>
+              <a:ext uri="{FF2B5EF4-FFF2-40B4-BE49-F238E27FC236}">
+                <a16:creationId xmlns:a16="http://schemas.microsoft.com/office/drawing/2014/main" id="{24E64234-7676-4E29-925E-BD49C8772E65}"/>
+              </a:ext>
+            </a:extLst>
+          </p:cNvPr>
+          <p:cNvCxnSpPr>
+            <a:cxnSpLocks/>
+          </p:cNvCxnSpPr>
+          <p:nvPr/>
+        </p:nvCxnSpPr>
+        <p:spPr>
+          <a:xfrm>
+            <a:off x="5353235" y="3133818"/>
+            <a:ext cx="1597981" cy="0"/>
+          </a:xfrm>
+          <a:prstGeom prst="line">
+            <a:avLst/>
+          </a:prstGeom>
+          <a:ln w="28575" cap="flat" cmpd="sng" algn="ctr">
+            <a:solidFill>
+              <a:srgbClr val="FF0000"/>
+            </a:solidFill>
+            <a:prstDash val="dash"/>
+            <a:round/>
+            <a:headEnd type="none" w="med" len="med"/>
+            <a:tailEnd type="none" w="med" len="med"/>
+          </a:ln>
+        </p:spPr>
+        <p:style>
+          <a:lnRef idx="0">
+            <a:scrgbClr r="0" g="0" b="0"/>
+          </a:lnRef>
+          <a:fillRef idx="0">
+            <a:scrgbClr r="0" g="0" b="0"/>
+          </a:fillRef>
+          <a:effectRef idx="0">
+            <a:scrgbClr r="0" g="0" b="0"/>
+          </a:effectRef>
+          <a:fontRef idx="minor">
+            <a:schemeClr val="tx1"/>
+          </a:fontRef>
+        </p:style>
+      </p:cxnSp>
     </p:spTree>
     <p:extLst>
       <p:ext uri="{BB962C8B-B14F-4D97-AF65-F5344CB8AC3E}">

</xml_diff>